<commit_message>
Remove highlighted (bold accent-coloured) bullet text from project 04 deck; all bullets plain
</commit_message>
<xml_diff>
--- a/ppt/X25100963_smart-city-monitoring.pptx
+++ b/ppt/X25100963_smart-city-monitoring.pptx
@@ -3449,9 +3449,9 @@
               </a:spcAft>
             </a:pPr>
             <a:r>
-              <a:rPr sz="1700" b="1">
-                <a:solidFill>
-                  <a:srgbClr val="C08A1F"/>
+              <a:rPr sz="1700" b="0">
+                <a:solidFill>
+                  <a:srgbClr val="232A26"/>
                 </a:solidFill>
                 <a:latin typeface="Verdana"/>
               </a:rPr>
@@ -3666,9 +3666,9 @@
               </a:spcAft>
             </a:pPr>
             <a:r>
-              <a:rPr sz="1500" b="1">
-                <a:solidFill>
-                  <a:srgbClr val="C08A1F"/>
+              <a:rPr sz="1500" b="0">
+                <a:solidFill>
+                  <a:srgbClr val="232A26"/>
                 </a:solidFill>
                 <a:latin typeface="Verdana"/>
               </a:rPr>
@@ -3714,9 +3714,9 @@
               </a:spcAft>
             </a:pPr>
             <a:r>
-              <a:rPr sz="1500" b="1">
-                <a:solidFill>
-                  <a:srgbClr val="C08A1F"/>
+              <a:rPr sz="1500" b="0">
+                <a:solidFill>
+                  <a:srgbClr val="232A26"/>
                 </a:solidFill>
                 <a:latin typeface="Verdana"/>
               </a:rPr>
@@ -3794,9 +3794,9 @@
               </a:spcAft>
             </a:pPr>
             <a:r>
-              <a:rPr sz="1500" b="1">
-                <a:solidFill>
-                  <a:srgbClr val="C08A1F"/>
+              <a:rPr sz="1500" b="0">
+                <a:solidFill>
+                  <a:srgbClr val="232A26"/>
                 </a:solidFill>
                 <a:latin typeface="Verdana"/>
               </a:rPr>
@@ -3995,9 +3995,9 @@
               </a:spcAft>
             </a:pPr>
             <a:r>
-              <a:rPr sz="1500" b="1">
-                <a:solidFill>
-                  <a:srgbClr val="C08A1F"/>
+              <a:rPr sz="1500" b="0">
+                <a:solidFill>
+                  <a:srgbClr val="232A26"/>
                 </a:solidFill>
                 <a:latin typeface="Verdana"/>
               </a:rPr>
@@ -4252,9 +4252,9 @@
               </a:spcAft>
             </a:pPr>
             <a:r>
-              <a:rPr sz="1500" b="1">
-                <a:solidFill>
-                  <a:srgbClr val="C08A1F"/>
+              <a:rPr sz="1500" b="0">
+                <a:solidFill>
+                  <a:srgbClr val="232A26"/>
                 </a:solidFill>
                 <a:latin typeface="Verdana"/>
               </a:rPr>
@@ -4284,9 +4284,9 @@
               </a:spcAft>
             </a:pPr>
             <a:r>
-              <a:rPr sz="1500" b="1">
-                <a:solidFill>
-                  <a:srgbClr val="C08A1F"/>
+              <a:rPr sz="1500" b="0">
+                <a:solidFill>
+                  <a:srgbClr val="232A26"/>
                 </a:solidFill>
                 <a:latin typeface="Verdana"/>
               </a:rPr>
@@ -4316,9 +4316,9 @@
               </a:spcAft>
             </a:pPr>
             <a:r>
-              <a:rPr sz="1500" b="1">
-                <a:solidFill>
-                  <a:srgbClr val="C08A1F"/>
+              <a:rPr sz="1500" b="0">
+                <a:solidFill>
+                  <a:srgbClr val="232A26"/>
                 </a:solidFill>
                 <a:latin typeface="Verdana"/>
               </a:rPr>
@@ -4348,9 +4348,9 @@
               </a:spcAft>
             </a:pPr>
             <a:r>
-              <a:rPr sz="1500" b="1">
-                <a:solidFill>
-                  <a:srgbClr val="C08A1F"/>
+              <a:rPr sz="1500" b="0">
+                <a:solidFill>
+                  <a:srgbClr val="232A26"/>
                 </a:solidFill>
                 <a:latin typeface="Verdana"/>
               </a:rPr>
@@ -4565,9 +4565,9 @@
               </a:spcAft>
             </a:pPr>
             <a:r>
-              <a:rPr sz="1700" b="1">
-                <a:solidFill>
-                  <a:srgbClr val="C08A1F"/>
+              <a:rPr sz="1700" b="0">
+                <a:solidFill>
+                  <a:srgbClr val="232A26"/>
                 </a:solidFill>
                 <a:latin typeface="Verdana"/>
               </a:rPr>

</xml_diff>

<commit_message>
Re-theme project 04 deck (teal band, badge-free) + all 8 unassigned spare decks to distinct new themes; clear bold highlighting
</commit_message>
<xml_diff>
--- a/ppt/X25100963_smart-city-monitoring.pptx
+++ b/ppt/X25100963_smart-city-monitoring.pptx
@@ -3108,7 +3108,7 @@
             <a:avLst/>
           </a:prstGeom>
           <a:solidFill>
-            <a:srgbClr val="C08A1F"/>
+            <a:srgbClr val="1F7A8C"/>
           </a:solidFill>
           <a:ln>
             <a:noFill/>
@@ -3139,20 +3139,179 @@
       </p:sp>
       <p:sp>
         <p:nvSpPr>
-          <p:cNvPr id="3" name="Rectangle 2"/>
+          <p:cNvPr id="3" name="TextBox 2"/>
+          <p:cNvSpPr txBox="1"/>
+          <p:nvPr/>
+        </p:nvSpPr>
+        <p:spPr>
+          <a:xfrm>
+            <a:off x="914400" y="2011680"/>
+            <a:ext cx="10332720" cy="1783080"/>
+          </a:xfrm>
+          <a:prstGeom prst="rect">
+            <a:avLst/>
+          </a:prstGeom>
+          <a:noFill/>
+        </p:spPr>
+        <p:txBody>
+          <a:bodyPr wrap="square" anchor="ctr">
+            <a:spAutoFit/>
+          </a:bodyPr>
+          <a:lstStyle/>
+          <a:p>
+            <a:pPr algn="ctr"/>
+            <a:r>
+              <a:rPr sz="3400" b="1" i="0">
+                <a:solidFill>
+                  <a:srgbClr val="FFFFFF"/>
+                </a:solidFill>
+                <a:latin typeface="Calibri"/>
+              </a:rPr>
+              <a:t>Smart City Operations Monitoring</a:t>
+            </a:r>
+          </a:p>
+        </p:txBody>
+      </p:sp>
+      <p:sp>
+        <p:nvSpPr>
+          <p:cNvPr id="4" name="TextBox 3"/>
+          <p:cNvSpPr txBox="1"/>
+          <p:nvPr/>
+        </p:nvSpPr>
+        <p:spPr>
+          <a:xfrm>
+            <a:off x="1371600" y="3840480"/>
+            <a:ext cx="9418320" cy="548640"/>
+          </a:xfrm>
+          <a:prstGeom prst="rect">
+            <a:avLst/>
+          </a:prstGeom>
+          <a:noFill/>
+        </p:spPr>
+        <p:txBody>
+          <a:bodyPr wrap="square" anchor="t">
+            <a:spAutoFit/>
+          </a:bodyPr>
+          <a:lstStyle/>
+          <a:p>
+            <a:pPr algn="ctr"/>
+            <a:r>
+              <a:rPr sz="1800" b="0" i="1">
+                <a:solidFill>
+                  <a:srgbClr val="C0D9DE"/>
+                </a:solidFill>
+                <a:latin typeface="Cambria"/>
+              </a:rPr>
+              <a:t>Ten street sensors, one edge relay, one serverless cloud pipeline</a:t>
+            </a:r>
+          </a:p>
+        </p:txBody>
+      </p:sp>
+      <p:sp>
+        <p:nvSpPr>
+          <p:cNvPr id="5" name="TextBox 4"/>
+          <p:cNvSpPr txBox="1"/>
+          <p:nvPr/>
+        </p:nvSpPr>
+        <p:spPr>
+          <a:xfrm>
+            <a:off x="1371600" y="4709160"/>
+            <a:ext cx="9418320" cy="1463040"/>
+          </a:xfrm>
+          <a:prstGeom prst="rect">
+            <a:avLst/>
+          </a:prstGeom>
+          <a:noFill/>
+        </p:spPr>
+        <p:txBody>
+          <a:bodyPr wrap="square" anchor="t">
+            <a:spAutoFit/>
+          </a:bodyPr>
+          <a:lstStyle/>
+          <a:p>
+            <a:pPr algn="ctr"/>
+            <a:r>
+              <a:rPr sz="1700" b="1" i="0">
+                <a:solidFill>
+                  <a:srgbClr val="FFFFFF"/>
+                </a:solidFill>
+                <a:latin typeface="Cambria"/>
+              </a:rPr>
+              <a:t>Mohammed Hassan Ahmed</a:t>
+            </a:r>
+          </a:p>
+          <a:p>
+            <a:pPr algn="ctr"/>
+            <a:r>
+              <a:rPr sz="1300" b="0" i="0">
+                <a:solidFill>
+                  <a:srgbClr val="A9CCD3"/>
+                </a:solidFill>
+                <a:latin typeface="Cambria"/>
+              </a:rPr>
+              <a:t>Student ID X25100963</a:t>
+            </a:r>
+          </a:p>
+          <a:p>
+            <a:pPr algn="ctr"/>
+            <a:r>
+              <a:rPr sz="1250" b="0" i="0">
+                <a:solidFill>
+                  <a:srgbClr val="A9CCD3"/>
+                </a:solidFill>
+                <a:latin typeface="Cambria"/>
+              </a:rPr>
+              <a:t>MSc in Cloud Computing   ·   Fog and Edge Computing (H9FECC)</a:t>
+            </a:r>
+          </a:p>
+          <a:p>
+            <a:pPr algn="ctr"/>
+            <a:r>
+              <a:rPr sz="1250" b="0" i="0">
+                <a:solidFill>
+                  <a:srgbClr val="A9CCD3"/>
+                </a:solidFill>
+                <a:latin typeface="Cambria"/>
+              </a:rPr>
+              <a:t>National College of Ireland</a:t>
+            </a:r>
+          </a:p>
+        </p:txBody>
+      </p:sp>
+    </p:spTree>
+  </p:cSld>
+  <p:clrMapOvr>
+    <a:masterClrMapping/>
+  </p:clrMapOvr>
+</p:sld>
+</file>
+
+<file path=ppt/slides/slide2.xml><?xml version="1.0" encoding="utf-8"?>
+<p:sld xmlns:a="http://schemas.openxmlformats.org/drawingml/2006/main" xmlns:p="http://schemas.openxmlformats.org/presentationml/2006/main" xmlns:r="http://schemas.openxmlformats.org/officeDocument/2006/relationships">
+  <p:cSld>
+    <p:spTree>
+      <p:nvGrpSpPr>
+        <p:cNvPr id="1" name=""/>
+        <p:cNvGrpSpPr/>
+        <p:nvPr/>
+      </p:nvGrpSpPr>
+      <p:grpSpPr/>
+      <p:sp>
+        <p:nvSpPr>
+          <p:cNvPr id="4" name="Rectangle 3"/>
           <p:cNvSpPr/>
           <p:nvPr/>
         </p:nvSpPr>
         <p:spPr>
           <a:xfrm>
-            <a:off x="9811512" y="1965960"/>
-            <a:ext cx="1554480" cy="82296"/>
+            <a:off x="0" y="0"/>
+            <a:ext cx="12191695" cy="1051560"/>
           </a:xfrm>
           <a:prstGeom prst="rect">
             <a:avLst/>
           </a:prstGeom>
           <a:solidFill>
-            <a:srgbClr val="FFFFFF"/>
+            <a:srgbClr val="1F7A8C"/>
           </a:solidFill>
           <a:ln>
             <a:noFill/>
@@ -3183,141 +3342,168 @@
       </p:sp>
       <p:sp>
         <p:nvSpPr>
-          <p:cNvPr id="4" name="TextBox 3"/>
-          <p:cNvSpPr txBox="1"/>
-          <p:nvPr/>
+          <p:cNvPr id="2" name="Title 1"/>
+          <p:cNvSpPr>
+            <a:spLocks noGrp="1"/>
+          </p:cNvSpPr>
+          <p:nvPr>
+            <p:ph type="title"/>
+          </p:nvPr>
         </p:nvSpPr>
         <p:spPr>
           <a:xfrm>
-            <a:off x="3200400" y="2194560"/>
-            <a:ext cx="8165592" cy="2103120"/>
+            <a:off x="640080" y="0"/>
+            <a:ext cx="10972800" cy="1051560"/>
           </a:xfrm>
-          <a:prstGeom prst="rect">
-            <a:avLst/>
-          </a:prstGeom>
-          <a:noFill/>
         </p:spPr>
         <p:txBody>
-          <a:bodyPr wrap="square" anchor="t">
-            <a:spAutoFit/>
-          </a:bodyPr>
-          <a:lstStyle/>
-          <a:p>
-            <a:pPr algn="r"/>
-            <a:r>
-              <a:rPr sz="3400" b="1" i="0">
+          <a:bodyPr wrap="square" anchor="ctr"/>
+          <a:lstStyle/>
+          <a:p>
+            <a:pPr algn="l"/>
+            <a:r>
+              <a:rPr b="1" sz="2400">
                 <a:solidFill>
                   <a:srgbClr val="FFFFFF"/>
                 </a:solidFill>
-                <a:latin typeface="Century Gothic"/>
+                <a:latin typeface="Calibri"/>
               </a:rPr>
-              <a:t>Smart City Operations Monitoring</a:t>
-            </a:r>
-          </a:p>
-        </p:txBody>
-      </p:sp>
-      <p:sp>
-        <p:nvSpPr>
-          <p:cNvPr id="5" name="TextBox 4"/>
-          <p:cNvSpPr txBox="1"/>
-          <p:nvPr/>
+              <a:t>Why occasional checking fails</a:t>
+            </a:r>
+          </a:p>
+        </p:txBody>
+      </p:sp>
+      <p:sp>
+        <p:nvSpPr>
+          <p:cNvPr id="3" name="Content Placeholder 2"/>
+          <p:cNvSpPr>
+            <a:spLocks noGrp="1"/>
+          </p:cNvSpPr>
+          <p:nvPr>
+            <p:ph idx="1"/>
+          </p:nvPr>
         </p:nvSpPr>
         <p:spPr>
           <a:xfrm>
-            <a:off x="4023360" y="4069080"/>
-            <a:ext cx="7342631" cy="640080"/>
+            <a:off x="658368" y="1371600"/>
+            <a:ext cx="10972800" cy="5029200"/>
           </a:xfrm>
-          <a:prstGeom prst="rect">
-            <a:avLst/>
-          </a:prstGeom>
-          <a:noFill/>
         </p:spPr>
         <p:txBody>
-          <a:bodyPr wrap="square" anchor="t">
-            <a:spAutoFit/>
+          <a:bodyPr wrap="square">
+            <a:normAutofit/>
           </a:bodyPr>
           <a:lstStyle/>
           <a:p>
-            <a:pPr algn="r"/>
-            <a:r>
-              <a:rPr sz="1700" b="0" i="1">
-                <a:solidFill>
-                  <a:srgbClr val="F1E5CD"/>
-                </a:solidFill>
-                <a:latin typeface="Verdana"/>
+            <a:pPr>
+              <a:spcAft>
+                <a:spcPts val="900"/>
+              </a:spcAft>
+            </a:pPr>
+            <a:r>
+              <a:rPr sz="1700" b="0">
+                <a:solidFill>
+                  <a:srgbClr val="232A26"/>
+                </a:solidFill>
+                <a:latin typeface="Cambria"/>
               </a:rPr>
-              <a:t>Ten street sensors, one edge relay, one serverless cloud pipeline</a:t>
-            </a:r>
-          </a:p>
-        </p:txBody>
-      </p:sp>
-      <p:sp>
-        <p:nvSpPr>
-          <p:cNvPr id="6" name="TextBox 5"/>
-          <p:cNvSpPr txBox="1"/>
-          <p:nvPr/>
-        </p:nvSpPr>
-        <p:spPr>
-          <a:xfrm>
-            <a:off x="3566160" y="4892040"/>
-            <a:ext cx="7799831" cy="1371600"/>
-          </a:xfrm>
-          <a:prstGeom prst="rect">
-            <a:avLst/>
-          </a:prstGeom>
-          <a:noFill/>
-        </p:spPr>
-        <p:txBody>
-          <a:bodyPr wrap="square" anchor="t">
-            <a:spAutoFit/>
-          </a:bodyPr>
-          <a:lstStyle/>
-          <a:p>
-            <a:pPr algn="r"/>
-            <a:r>
-              <a:rPr sz="1700" b="1" i="0">
-                <a:solidFill>
-                  <a:srgbClr val="FFFFFF"/>
-                </a:solidFill>
-                <a:latin typeface="Verdana"/>
+              <a:t>Congestion, pollution spikes and full car parks build and fade within minutes, between any two manual checks.</a:t>
+            </a:r>
+          </a:p>
+          <a:p>
+            <a:pPr>
+              <a:spcAft>
+                <a:spcPts val="900"/>
+              </a:spcAft>
+            </a:pPr>
+            <a:r>
+              <a:rPr sz="1700" b="0">
+                <a:solidFill>
+                  <a:srgbClr val="232A26"/>
+                </a:solidFill>
+                <a:latin typeface="Cambria"/>
               </a:rPr>
-              <a:t>Mohammed Hassan Ahmed</a:t>
-            </a:r>
-          </a:p>
-          <a:p>
-            <a:pPr algn="r"/>
-            <a:r>
-              <a:rPr sz="1300" b="0" i="0">
-                <a:solidFill>
-                  <a:srgbClr val="EAD9B7"/>
-                </a:solidFill>
-                <a:latin typeface="Verdana"/>
+              <a:t>A patrol or a monthly meter read captures one moment; the breach that matters happens after the clipboard leaves.</a:t>
+            </a:r>
+          </a:p>
+          <a:p>
+            <a:pPr>
+              <a:spcAft>
+                <a:spcPts val="900"/>
+              </a:spcAft>
+            </a:pPr>
+            <a:r>
+              <a:rPr sz="1700" b="0">
+                <a:solidFill>
+                  <a:srgbClr val="232A26"/>
+                </a:solidFill>
+                <a:latin typeface="Cambria"/>
               </a:rPr>
-              <a:t>Student ID X25100963</a:t>
-            </a:r>
-          </a:p>
-          <a:p>
-            <a:pPr algn="r"/>
-            <a:r>
-              <a:rPr sz="1250" b="0" i="0">
-                <a:solidFill>
-                  <a:srgbClr val="EAD9B7"/>
-                </a:solidFill>
-                <a:latin typeface="Verdana"/>
+              <a:t>Streaming every raw reading to a distant cloud is the other extreme: heavy, slow and costly at city scale.</a:t>
+            </a:r>
+          </a:p>
+          <a:p>
+            <a:pPr>
+              <a:spcAft>
+                <a:spcPts val="900"/>
+              </a:spcAft>
+            </a:pPr>
+            <a:r>
+              <a:rPr sz="1700" b="0">
+                <a:solidFill>
+                  <a:srgbClr val="232A26"/>
+                </a:solidFill>
+                <a:latin typeface="Cambria"/>
               </a:rPr>
-              <a:t>MSc in Cloud Computing   ·   Fog and Edge Computing (H9FECC)</a:t>
-            </a:r>
-          </a:p>
-          <a:p>
-            <a:pPr algn="r"/>
-            <a:r>
-              <a:rPr sz="1250" b="0" i="0">
-                <a:solidFill>
-                  <a:srgbClr val="EAD9B7"/>
-                </a:solidFill>
-                <a:latin typeface="Verdana"/>
+              <a:t>What a city needs is continuous local watching, with only compact summaries and alerts leaving the street.</a:t>
+            </a:r>
+          </a:p>
+          <a:p>
+            <a:pPr>
+              <a:spcAft>
+                <a:spcPts val="900"/>
+              </a:spcAft>
+            </a:pPr>
+            <a:r>
+              <a:rPr sz="1700" b="0">
+                <a:solidFill>
+                  <a:srgbClr val="232A26"/>
+                </a:solidFill>
+                <a:latin typeface="Cambria"/>
               </a:rPr>
-              <a:t>National College of Ireland</a:t>
+              <a:t>35 micrograms per cubic metre is the pipeline's PM2.5 alert line; an air quality breach can rise and fade between manual reads.</a:t>
+            </a:r>
+          </a:p>
+          <a:p>
+            <a:pPr>
+              <a:spcAft>
+                <a:spcPts val="900"/>
+              </a:spcAft>
+            </a:pPr>
+            <a:r>
+              <a:rPr sz="1700" b="0">
+                <a:solidFill>
+                  <a:srgbClr val="232A26"/>
+                </a:solidFill>
+                <a:latin typeface="Cambria"/>
+              </a:rPr>
+              <a:t>75 dB is the noise violation threshold; residents feel every extra minute it goes unnoticed.</a:t>
+            </a:r>
+          </a:p>
+          <a:p>
+            <a:pPr>
+              <a:spcAft>
+                <a:spcPts val="900"/>
+              </a:spcAft>
+            </a:pPr>
+            <a:r>
+              <a:rPr sz="1700" b="0">
+                <a:solidFill>
+                  <a:srgbClr val="232A26"/>
+                </a:solidFill>
+                <a:latin typeface="Cambria"/>
+              </a:rPr>
+              <a:t>Each of ten street sensors reports one reading every 2 to 5 seconds continuously, and no manual process keeps up with that.</a:t>
             </a:r>
           </a:p>
         </p:txBody>
@@ -3330,7 +3516,7 @@
 </p:sld>
 </file>
 
-<file path=ppt/slides/slide2.xml><?xml version="1.0" encoding="utf-8"?>
+<file path=ppt/slides/slide3.xml><?xml version="1.0" encoding="utf-8"?>
 <p:sld xmlns:a="http://schemas.openxmlformats.org/drawingml/2006/main" xmlns:p="http://schemas.openxmlformats.org/presentationml/2006/main" xmlns:r="http://schemas.openxmlformats.org/officeDocument/2006/relationships">
   <p:cSld>
     <p:spTree>
@@ -3342,188 +3528,20 @@
       <p:grpSpPr/>
       <p:sp>
         <p:nvSpPr>
-          <p:cNvPr id="2" name="Title 1"/>
-          <p:cNvSpPr>
-            <a:spLocks noGrp="1"/>
-          </p:cNvSpPr>
-          <p:nvPr>
-            <p:ph type="title"/>
-          </p:nvPr>
-        </p:nvSpPr>
-        <p:spPr>
-          <a:xfrm>
-            <a:off x="1691640" y="457200"/>
-            <a:ext cx="9875520" cy="868680"/>
-          </a:xfrm>
-        </p:spPr>
-        <p:txBody>
-          <a:bodyPr wrap="square" anchor="ctr"/>
-          <a:lstStyle/>
-          <a:p>
-            <a:pPr algn="l"/>
-            <a:r>
-              <a:rPr b="1" sz="2700">
-                <a:solidFill>
-                  <a:srgbClr val="C08A1F"/>
-                </a:solidFill>
-                <a:latin typeface="Century Gothic"/>
-              </a:rPr>
-              <a:t>Why occasional checking fails</a:t>
-            </a:r>
-          </a:p>
-        </p:txBody>
-      </p:sp>
-      <p:sp>
-        <p:nvSpPr>
-          <p:cNvPr id="3" name="Content Placeholder 2"/>
-          <p:cNvSpPr>
-            <a:spLocks noGrp="1"/>
-          </p:cNvSpPr>
-          <p:nvPr>
-            <p:ph idx="1"/>
-          </p:nvPr>
-        </p:nvSpPr>
-        <p:spPr>
-          <a:xfrm>
-            <a:off x="658368" y="1600200"/>
-            <a:ext cx="10972800" cy="4663440"/>
-          </a:xfrm>
-        </p:spPr>
-        <p:txBody>
-          <a:bodyPr wrap="square">
-            <a:normAutofit/>
-          </a:bodyPr>
-          <a:lstStyle/>
-          <a:p>
-            <a:pPr>
-              <a:spcAft>
-                <a:spcPts val="900"/>
-              </a:spcAft>
-            </a:pPr>
-            <a:r>
-              <a:rPr sz="1700" b="0">
-                <a:solidFill>
-                  <a:srgbClr val="232A26"/>
-                </a:solidFill>
-                <a:latin typeface="Verdana"/>
-              </a:rPr>
-              <a:t>Congestion, pollution spikes and full car parks build and fade within minutes, between any two manual checks.</a:t>
-            </a:r>
-          </a:p>
-          <a:p>
-            <a:pPr>
-              <a:spcAft>
-                <a:spcPts val="900"/>
-              </a:spcAft>
-            </a:pPr>
-            <a:r>
-              <a:rPr sz="1700" b="0">
-                <a:solidFill>
-                  <a:srgbClr val="232A26"/>
-                </a:solidFill>
-                <a:latin typeface="Verdana"/>
-              </a:rPr>
-              <a:t>A patrol or a monthly meter read captures one moment; the breach that matters happens after the clipboard leaves.</a:t>
-            </a:r>
-          </a:p>
-          <a:p>
-            <a:pPr>
-              <a:spcAft>
-                <a:spcPts val="900"/>
-              </a:spcAft>
-            </a:pPr>
-            <a:r>
-              <a:rPr sz="1700" b="0">
-                <a:solidFill>
-                  <a:srgbClr val="232A26"/>
-                </a:solidFill>
-                <a:latin typeface="Verdana"/>
-              </a:rPr>
-              <a:t>Streaming every raw reading to a distant cloud is the other extreme: heavy, slow and costly at city scale.</a:t>
-            </a:r>
-          </a:p>
-          <a:p>
-            <a:pPr>
-              <a:spcAft>
-                <a:spcPts val="900"/>
-              </a:spcAft>
-            </a:pPr>
-            <a:r>
-              <a:rPr sz="1700" b="0">
-                <a:solidFill>
-                  <a:srgbClr val="232A26"/>
-                </a:solidFill>
-                <a:latin typeface="Verdana"/>
-              </a:rPr>
-              <a:t>What a city needs is continuous local watching, with only compact summaries and alerts leaving the street.</a:t>
-            </a:r>
-          </a:p>
-          <a:p>
-            <a:pPr>
-              <a:spcAft>
-                <a:spcPts val="900"/>
-              </a:spcAft>
-            </a:pPr>
-            <a:r>
-              <a:rPr sz="1700" b="0">
-                <a:solidFill>
-                  <a:srgbClr val="232A26"/>
-                </a:solidFill>
-                <a:latin typeface="Verdana"/>
-              </a:rPr>
-              <a:t>35 micrograms per cubic metre is the pipeline's PM2.5 alert line; an air quality breach can rise and fade between manual reads.</a:t>
-            </a:r>
-          </a:p>
-          <a:p>
-            <a:pPr>
-              <a:spcAft>
-                <a:spcPts val="900"/>
-              </a:spcAft>
-            </a:pPr>
-            <a:r>
-              <a:rPr sz="1700" b="0">
-                <a:solidFill>
-                  <a:srgbClr val="232A26"/>
-                </a:solidFill>
-                <a:latin typeface="Verdana"/>
-              </a:rPr>
-              <a:t>75 dB is the noise violation threshold; residents feel every extra minute it goes unnoticed.</a:t>
-            </a:r>
-          </a:p>
-          <a:p>
-            <a:pPr>
-              <a:spcAft>
-                <a:spcPts val="900"/>
-              </a:spcAft>
-            </a:pPr>
-            <a:r>
-              <a:rPr sz="1700" b="0">
-                <a:solidFill>
-                  <a:srgbClr val="232A26"/>
-                </a:solidFill>
-                <a:latin typeface="Verdana"/>
-              </a:rPr>
-              <a:t>Each of ten street sensors reports one reading every 2 to 5 seconds continuously, and no manual process keeps up with that.</a:t>
-            </a:r>
-          </a:p>
-        </p:txBody>
-      </p:sp>
-      <p:sp>
-        <p:nvSpPr>
           <p:cNvPr id="4" name="Rectangle 3"/>
           <p:cNvSpPr/>
           <p:nvPr/>
         </p:nvSpPr>
         <p:spPr>
           <a:xfrm>
-            <a:off x="640080" y="457200"/>
-            <a:ext cx="868680" cy="868680"/>
+            <a:off x="0" y="0"/>
+            <a:ext cx="12191695" cy="1051560"/>
           </a:xfrm>
           <a:prstGeom prst="rect">
             <a:avLst/>
           </a:prstGeom>
           <a:solidFill>
-            <a:srgbClr val="C08A1F"/>
+            <a:srgbClr val="1F7A8C"/>
           </a:solidFill>
           <a:ln>
             <a:noFill/>
@@ -3554,35 +3572,200 @@
       </p:sp>
       <p:sp>
         <p:nvSpPr>
-          <p:cNvPr id="5" name="TextBox 4"/>
-          <p:cNvSpPr txBox="1"/>
-          <p:nvPr/>
+          <p:cNvPr id="2" name="Title 1"/>
+          <p:cNvSpPr>
+            <a:spLocks noGrp="1"/>
+          </p:cNvSpPr>
+          <p:nvPr>
+            <p:ph type="title"/>
+          </p:nvPr>
         </p:nvSpPr>
         <p:spPr>
           <a:xfrm>
-            <a:off x="640080" y="457200"/>
-            <a:ext cx="868680" cy="868680"/>
+            <a:off x="640080" y="0"/>
+            <a:ext cx="10972800" cy="1051560"/>
           </a:xfrm>
-          <a:prstGeom prst="rect">
-            <a:avLst/>
-          </a:prstGeom>
-          <a:noFill/>
         </p:spPr>
         <p:txBody>
-          <a:bodyPr wrap="square" anchor="ctr">
-            <a:spAutoFit/>
+          <a:bodyPr wrap="square" anchor="ctr"/>
+          <a:lstStyle/>
+          <a:p>
+            <a:pPr algn="l"/>
+            <a:r>
+              <a:rPr b="1" sz="2400">
+                <a:solidFill>
+                  <a:srgbClr val="FFFFFF"/>
+                </a:solidFill>
+                <a:latin typeface="Calibri"/>
+              </a:rPr>
+              <a:t>How it works: edge to cloud</a:t>
+            </a:r>
+          </a:p>
+        </p:txBody>
+      </p:sp>
+      <p:sp>
+        <p:nvSpPr>
+          <p:cNvPr id="3" name="Content Placeholder 2"/>
+          <p:cNvSpPr>
+            <a:spLocks noGrp="1"/>
+          </p:cNvSpPr>
+          <p:nvPr>
+            <p:ph idx="1"/>
+          </p:nvPr>
+        </p:nvSpPr>
+        <p:spPr>
+          <a:xfrm>
+            <a:off x="658368" y="1371600"/>
+            <a:ext cx="10972800" cy="5029200"/>
+          </a:xfrm>
+        </p:spPr>
+        <p:txBody>
+          <a:bodyPr wrap="square">
+            <a:normAutofit/>
           </a:bodyPr>
           <a:lstStyle/>
           <a:p>
-            <a:pPr algn="ctr"/>
-            <a:r>
-              <a:rPr sz="2600" b="1" i="0">
-                <a:solidFill>
-                  <a:srgbClr val="FFFFFF"/>
-                </a:solidFill>
-                <a:latin typeface="Century Gothic"/>
+            <a:pPr>
+              <a:spcAft>
+                <a:spcPts val="600"/>
+              </a:spcAft>
+            </a:pPr>
+            <a:r>
+              <a:rPr sz="1500" b="0">
+                <a:solidFill>
+                  <a:srgbClr val="232A26"/>
+                </a:solidFill>
+                <a:latin typeface="Cambria"/>
               </a:rPr>
-              <a:t>1</a:t>
+              <a:t>City edge:</a:t>
+            </a:r>
+          </a:p>
+          <a:p>
+            <a:pPr lvl="1">
+              <a:spcAft>
+                <a:spcPts val="600"/>
+              </a:spcAft>
+            </a:pPr>
+            <a:r>
+              <a:rPr sz="1300" b="0">
+                <a:solidFill>
+                  <a:srgbClr val="232A26"/>
+                </a:solidFill>
+                <a:latin typeface="Cambria"/>
+              </a:rPr>
+              <a:t>Street sensors: 10 devices, 5 metrics, 2 zones.</a:t>
+            </a:r>
+          </a:p>
+          <a:p>
+            <a:pPr lvl="1">
+              <a:spcAft>
+                <a:spcPts val="600"/>
+              </a:spcAft>
+            </a:pPr>
+            <a:r>
+              <a:rPr sz="1300" b="0">
+                <a:solidFill>
+                  <a:srgbClr val="232A26"/>
+                </a:solidFill>
+                <a:latin typeface="Cambria"/>
+              </a:rPr>
+              <a:t>Fog node windows, aggregates and alerts, with a 10 second aggregation window at the edge relay.</a:t>
+            </a:r>
+          </a:p>
+          <a:p>
+            <a:pPr>
+              <a:spcAft>
+                <a:spcPts val="600"/>
+              </a:spcAft>
+            </a:pPr>
+            <a:r>
+              <a:rPr sz="1500" b="0">
+                <a:solidFill>
+                  <a:srgbClr val="232A26"/>
+                </a:solidFill>
+                <a:latin typeface="Cambria"/>
+              </a:rPr>
+              <a:t>AWS cloud:</a:t>
+            </a:r>
+          </a:p>
+          <a:p>
+            <a:pPr lvl="1">
+              <a:spcAft>
+                <a:spcPts val="600"/>
+              </a:spcAft>
+            </a:pPr>
+            <a:r>
+              <a:rPr sz="1300" b="0">
+                <a:solidFill>
+                  <a:srgbClr val="232A26"/>
+                </a:solidFill>
+                <a:latin typeface="Cambria"/>
+              </a:rPr>
+              <a:t>Amazon SQS aggregate queue, AWS Lambda serverless ingest, and Amazon DynamoDB durable store.</a:t>
+            </a:r>
+          </a:p>
+          <a:p>
+            <a:pPr lvl="1">
+              <a:spcAft>
+                <a:spcPts val="600"/>
+              </a:spcAft>
+            </a:pPr>
+            <a:r>
+              <a:rPr sz="1300" b="0">
+                <a:solidFill>
+                  <a:srgbClr val="232A26"/>
+                </a:solidFill>
+                <a:latin typeface="Cambria"/>
+              </a:rPr>
+              <a:t>Live dashboard on Amazon S3 and API Gateway.</a:t>
+            </a:r>
+          </a:p>
+          <a:p>
+            <a:pPr>
+              <a:spcAft>
+                <a:spcPts val="600"/>
+              </a:spcAft>
+            </a:pPr>
+            <a:r>
+              <a:rPr sz="1500" b="0">
+                <a:solidFill>
+                  <a:srgbClr val="232A26"/>
+                </a:solidFill>
+                <a:latin typeface="Cambria"/>
+              </a:rPr>
+              <a:t>5 alert rules are assessed beside the sensors, not in the cloud.</a:t>
+            </a:r>
+          </a:p>
+          <a:p>
+            <a:pPr>
+              <a:spcAft>
+                <a:spcPts val="600"/>
+              </a:spcAft>
+            </a:pPr>
+            <a:r>
+              <a:rPr sz="1500" b="0">
+                <a:solidFill>
+                  <a:srgbClr val="232A26"/>
+                </a:solidFill>
+                <a:latin typeface="Cambria"/>
+              </a:rPr>
+              <a:t>1 scripted step: verified locally on an AWS emulator, deploys to AWS unchanged.</a:t>
+            </a:r>
+          </a:p>
+          <a:p>
+            <a:pPr>
+              <a:spcAft>
+                <a:spcPts val="600"/>
+              </a:spcAft>
+            </a:pPr>
+            <a:r>
+              <a:rPr sz="1500" b="0">
+                <a:solidFill>
+                  <a:srgbClr val="232A26"/>
+                </a:solidFill>
+                <a:latin typeface="Cambria"/>
+              </a:rPr>
+              <a:t>Each zone and metric leaves the street as one compact summary every ten seconds, alerts already attached.</a:t>
             </a:r>
           </a:p>
         </p:txBody>
@@ -3595,7 +3778,7 @@
 </p:sld>
 </file>
 
-<file path=ppt/slides/slide3.xml><?xml version="1.0" encoding="utf-8"?>
+<file path=ppt/slides/slide4.xml><?xml version="1.0" encoding="utf-8"?>
 <p:sld xmlns:a="http://schemas.openxmlformats.org/drawingml/2006/main" xmlns:p="http://schemas.openxmlformats.org/presentationml/2006/main" xmlns:r="http://schemas.openxmlformats.org/officeDocument/2006/relationships">
   <p:cSld>
     <p:spTree>
@@ -3607,220 +3790,20 @@
       <p:grpSpPr/>
       <p:sp>
         <p:nvSpPr>
-          <p:cNvPr id="2" name="Title 1"/>
-          <p:cNvSpPr>
-            <a:spLocks noGrp="1"/>
-          </p:cNvSpPr>
-          <p:nvPr>
-            <p:ph type="title"/>
-          </p:nvPr>
-        </p:nvSpPr>
-        <p:spPr>
-          <a:xfrm>
-            <a:off x="1691640" y="457200"/>
-            <a:ext cx="9875520" cy="868680"/>
-          </a:xfrm>
-        </p:spPr>
-        <p:txBody>
-          <a:bodyPr wrap="square" anchor="ctr"/>
-          <a:lstStyle/>
-          <a:p>
-            <a:pPr algn="l"/>
-            <a:r>
-              <a:rPr b="1" sz="2700">
-                <a:solidFill>
-                  <a:srgbClr val="C08A1F"/>
-                </a:solidFill>
-                <a:latin typeface="Century Gothic"/>
-              </a:rPr>
-              <a:t>How it works: edge to cloud</a:t>
-            </a:r>
-          </a:p>
-        </p:txBody>
-      </p:sp>
-      <p:sp>
-        <p:nvSpPr>
-          <p:cNvPr id="3" name="Content Placeholder 2"/>
-          <p:cNvSpPr>
-            <a:spLocks noGrp="1"/>
-          </p:cNvSpPr>
-          <p:nvPr>
-            <p:ph idx="1"/>
-          </p:nvPr>
-        </p:nvSpPr>
-        <p:spPr>
-          <a:xfrm>
-            <a:off x="658368" y="1600200"/>
-            <a:ext cx="10972800" cy="4663440"/>
-          </a:xfrm>
-        </p:spPr>
-        <p:txBody>
-          <a:bodyPr wrap="square">
-            <a:normAutofit/>
-          </a:bodyPr>
-          <a:lstStyle/>
-          <a:p>
-            <a:pPr>
-              <a:spcAft>
-                <a:spcPts val="600"/>
-              </a:spcAft>
-            </a:pPr>
-            <a:r>
-              <a:rPr sz="1500" b="0">
-                <a:solidFill>
-                  <a:srgbClr val="232A26"/>
-                </a:solidFill>
-                <a:latin typeface="Verdana"/>
-              </a:rPr>
-              <a:t>City edge:</a:t>
-            </a:r>
-          </a:p>
-          <a:p>
-            <a:pPr lvl="1">
-              <a:spcAft>
-                <a:spcPts val="600"/>
-              </a:spcAft>
-            </a:pPr>
-            <a:r>
-              <a:rPr sz="1300" b="0">
-                <a:solidFill>
-                  <a:srgbClr val="232A26"/>
-                </a:solidFill>
-                <a:latin typeface="Verdana"/>
-              </a:rPr>
-              <a:t>Street sensors: 10 devices, 5 metrics, 2 zones.</a:t>
-            </a:r>
-          </a:p>
-          <a:p>
-            <a:pPr lvl="1">
-              <a:spcAft>
-                <a:spcPts val="600"/>
-              </a:spcAft>
-            </a:pPr>
-            <a:r>
-              <a:rPr sz="1300" b="0">
-                <a:solidFill>
-                  <a:srgbClr val="232A26"/>
-                </a:solidFill>
-                <a:latin typeface="Verdana"/>
-              </a:rPr>
-              <a:t>Fog node windows, aggregates and alerts, with a 10 second aggregation window at the edge relay.</a:t>
-            </a:r>
-          </a:p>
-          <a:p>
-            <a:pPr>
-              <a:spcAft>
-                <a:spcPts val="600"/>
-              </a:spcAft>
-            </a:pPr>
-            <a:r>
-              <a:rPr sz="1500" b="0">
-                <a:solidFill>
-                  <a:srgbClr val="232A26"/>
-                </a:solidFill>
-                <a:latin typeface="Verdana"/>
-              </a:rPr>
-              <a:t>AWS cloud:</a:t>
-            </a:r>
-          </a:p>
-          <a:p>
-            <a:pPr lvl="1">
-              <a:spcAft>
-                <a:spcPts val="600"/>
-              </a:spcAft>
-            </a:pPr>
-            <a:r>
-              <a:rPr sz="1300" b="0">
-                <a:solidFill>
-                  <a:srgbClr val="232A26"/>
-                </a:solidFill>
-                <a:latin typeface="Verdana"/>
-              </a:rPr>
-              <a:t>Amazon SQS aggregate queue, AWS Lambda serverless ingest, and Amazon DynamoDB durable store.</a:t>
-            </a:r>
-          </a:p>
-          <a:p>
-            <a:pPr lvl="1">
-              <a:spcAft>
-                <a:spcPts val="600"/>
-              </a:spcAft>
-            </a:pPr>
-            <a:r>
-              <a:rPr sz="1300" b="0">
-                <a:solidFill>
-                  <a:srgbClr val="232A26"/>
-                </a:solidFill>
-                <a:latin typeface="Verdana"/>
-              </a:rPr>
-              <a:t>Live dashboard on Amazon S3 and API Gateway.</a:t>
-            </a:r>
-          </a:p>
-          <a:p>
-            <a:pPr>
-              <a:spcAft>
-                <a:spcPts val="600"/>
-              </a:spcAft>
-            </a:pPr>
-            <a:r>
-              <a:rPr sz="1500" b="0">
-                <a:solidFill>
-                  <a:srgbClr val="232A26"/>
-                </a:solidFill>
-                <a:latin typeface="Verdana"/>
-              </a:rPr>
-              <a:t>5 alert rules are assessed beside the sensors, not in the cloud.</a:t>
-            </a:r>
-          </a:p>
-          <a:p>
-            <a:pPr>
-              <a:spcAft>
-                <a:spcPts val="600"/>
-              </a:spcAft>
-            </a:pPr>
-            <a:r>
-              <a:rPr sz="1500" b="0">
-                <a:solidFill>
-                  <a:srgbClr val="232A26"/>
-                </a:solidFill>
-                <a:latin typeface="Verdana"/>
-              </a:rPr>
-              <a:t>1 scripted step: verified locally on an AWS emulator, deploys to AWS unchanged.</a:t>
-            </a:r>
-          </a:p>
-          <a:p>
-            <a:pPr>
-              <a:spcAft>
-                <a:spcPts val="600"/>
-              </a:spcAft>
-            </a:pPr>
-            <a:r>
-              <a:rPr sz="1500" b="0">
-                <a:solidFill>
-                  <a:srgbClr val="232A26"/>
-                </a:solidFill>
-                <a:latin typeface="Verdana"/>
-              </a:rPr>
-              <a:t>Each zone and metric leaves the street as one compact summary every ten seconds, alerts already attached.</a:t>
-            </a:r>
-          </a:p>
-        </p:txBody>
-      </p:sp>
-      <p:sp>
-        <p:nvSpPr>
           <p:cNvPr id="4" name="Rectangle 3"/>
           <p:cNvSpPr/>
           <p:nvPr/>
         </p:nvSpPr>
         <p:spPr>
           <a:xfrm>
-            <a:off x="640080" y="457200"/>
-            <a:ext cx="868680" cy="868680"/>
+            <a:off x="0" y="0"/>
+            <a:ext cx="12191695" cy="1051560"/>
           </a:xfrm>
           <a:prstGeom prst="rect">
             <a:avLst/>
           </a:prstGeom>
           <a:solidFill>
-            <a:srgbClr val="C08A1F"/>
+            <a:srgbClr val="1F7A8C"/>
           </a:solidFill>
           <a:ln>
             <a:noFill/>
@@ -3851,104 +3834,51 @@
       </p:sp>
       <p:sp>
         <p:nvSpPr>
-          <p:cNvPr id="5" name="TextBox 4"/>
-          <p:cNvSpPr txBox="1"/>
-          <p:nvPr/>
+          <p:cNvPr id="2" name="Title 1"/>
+          <p:cNvSpPr>
+            <a:spLocks noGrp="1"/>
+          </p:cNvSpPr>
+          <p:nvPr>
+            <p:ph type="title"/>
+          </p:nvPr>
         </p:nvSpPr>
         <p:spPr>
           <a:xfrm>
-            <a:off x="640080" y="457200"/>
-            <a:ext cx="868680" cy="868680"/>
+            <a:off x="640080" y="0"/>
+            <a:ext cx="10972800" cy="1051560"/>
           </a:xfrm>
-          <a:prstGeom prst="rect">
-            <a:avLst/>
-          </a:prstGeom>
-          <a:noFill/>
         </p:spPr>
         <p:txBody>
-          <a:bodyPr wrap="square" anchor="ctr">
-            <a:spAutoFit/>
-          </a:bodyPr>
-          <a:lstStyle/>
-          <a:p>
-            <a:pPr algn="ctr"/>
-            <a:r>
-              <a:rPr sz="2600" b="1" i="0">
+          <a:bodyPr wrap="square" anchor="ctr"/>
+          <a:lstStyle/>
+          <a:p>
+            <a:pPr algn="l"/>
+            <a:r>
+              <a:rPr b="1" sz="2400">
                 <a:solidFill>
                   <a:srgbClr val="FFFFFF"/>
                 </a:solidFill>
-                <a:latin typeface="Century Gothic"/>
+                <a:latin typeface="Calibri"/>
               </a:rPr>
-              <a:t>2</a:t>
-            </a:r>
-          </a:p>
-        </p:txBody>
-      </p:sp>
-    </p:spTree>
-  </p:cSld>
-  <p:clrMapOvr>
-    <a:masterClrMapping/>
-  </p:clrMapOvr>
-</p:sld>
-</file>
-
-<file path=ppt/slides/slide4.xml><?xml version="1.0" encoding="utf-8"?>
-<p:sld xmlns:a="http://schemas.openxmlformats.org/drawingml/2006/main" xmlns:p="http://schemas.openxmlformats.org/presentationml/2006/main" xmlns:r="http://schemas.openxmlformats.org/officeDocument/2006/relationships">
-  <p:cSld>
-    <p:spTree>
-      <p:nvGrpSpPr>
-        <p:cNvPr id="1" name=""/>
-        <p:cNvGrpSpPr/>
-        <p:nvPr/>
-      </p:nvGrpSpPr>
-      <p:grpSpPr/>
-      <p:sp>
-        <p:nvSpPr>
-          <p:cNvPr id="2" name="Title 1"/>
-          <p:cNvSpPr>
-            <a:spLocks noGrp="1"/>
-          </p:cNvSpPr>
-          <p:nvPr>
-            <p:ph type="title"/>
+              <a:t>Demonstration highlights</a:t>
+            </a:r>
+          </a:p>
+        </p:txBody>
+      </p:sp>
+      <p:sp>
+        <p:nvSpPr>
+          <p:cNvPr id="3" name="Content Placeholder 2"/>
+          <p:cNvSpPr>
+            <a:spLocks noGrp="1"/>
+          </p:cNvSpPr>
+          <p:nvPr>
+            <p:ph idx="1"/>
           </p:nvPr>
         </p:nvSpPr>
         <p:spPr>
           <a:xfrm>
-            <a:off x="1691640" y="457200"/>
-            <a:ext cx="9875520" cy="868680"/>
-          </a:xfrm>
-        </p:spPr>
-        <p:txBody>
-          <a:bodyPr wrap="square" anchor="ctr"/>
-          <a:lstStyle/>
-          <a:p>
-            <a:pPr algn="l"/>
-            <a:r>
-              <a:rPr b="1" sz="2700">
-                <a:solidFill>
-                  <a:srgbClr val="C08A1F"/>
-                </a:solidFill>
-                <a:latin typeface="Century Gothic"/>
-              </a:rPr>
-              <a:t>Demonstration highlights</a:t>
-            </a:r>
-          </a:p>
-        </p:txBody>
-      </p:sp>
-      <p:sp>
-        <p:nvSpPr>
-          <p:cNvPr id="3" name="Content Placeholder 2"/>
-          <p:cNvSpPr>
-            <a:spLocks noGrp="1"/>
-          </p:cNvSpPr>
-          <p:nvPr>
-            <p:ph idx="1"/>
-          </p:nvPr>
-        </p:nvSpPr>
-        <p:spPr>
-          <a:xfrm>
-            <a:off x="658368" y="1600200"/>
-            <a:ext cx="5760720" cy="4572000"/>
+            <a:off x="658368" y="1371600"/>
+            <a:ext cx="5760720" cy="4937760"/>
           </a:xfrm>
         </p:spPr>
         <p:txBody>
@@ -3967,7 +3897,7 @@
                 <a:solidFill>
                   <a:srgbClr val="232A26"/>
                 </a:solidFill>
-                <a:latin typeface="Verdana"/>
+                <a:latin typeface="Cambria"/>
               </a:rPr>
               <a:t>Dashboard captured from the running stack.</a:t>
             </a:r>
@@ -3983,7 +3913,7 @@
                 <a:solidFill>
                   <a:srgbClr val="232A26"/>
                 </a:solidFill>
-                <a:latin typeface="Verdana"/>
+                <a:latin typeface="Cambria"/>
               </a:rPr>
               <a:t>Two zones reporting, five metrics per zone, citywide trend charts, and the health footer along the bottom edge.</a:t>
             </a:r>
@@ -3999,7 +3929,7 @@
                 <a:solidFill>
                   <a:srgbClr val="232A26"/>
                 </a:solidFill>
-                <a:latin typeface="Verdana"/>
+                <a:latin typeface="Cambria"/>
               </a:rPr>
               <a:t>All pipeline health checks green: edge relay online, queue reachable, Lambda deployed, records archived.</a:t>
             </a:r>
@@ -4015,7 +3945,7 @@
                 <a:solidFill>
                   <a:srgbClr val="232A26"/>
                 </a:solidFill>
-                <a:latin typeface="Verdana"/>
+                <a:latin typeface="Cambria"/>
               </a:rPr>
               <a:t>62 automated tests pass across the sensor, fog, processor and dashboard modules.</a:t>
             </a:r>
@@ -4031,7 +3961,7 @@
                 <a:solidFill>
                   <a:srgbClr val="232A26"/>
                 </a:solidFill>
-                <a:latin typeface="Verdana"/>
+                <a:latin typeface="Cambria"/>
               </a:rPr>
               <a:t>2,000-message burst absorbed: load test fired through 32 parallel workers as scalability evidence.</a:t>
             </a:r>
@@ -4047,95 +3977,16 @@
                 <a:solidFill>
                   <a:srgbClr val="232A26"/>
                 </a:solidFill>
-                <a:latin typeface="Verdana"/>
+                <a:latin typeface="Cambria"/>
               </a:rPr>
               <a:t>Five alert rules fire live: congestion, air quality, noise, parking and low visibility.</a:t>
             </a:r>
           </a:p>
         </p:txBody>
       </p:sp>
-      <p:sp>
-        <p:nvSpPr>
-          <p:cNvPr id="4" name="Rectangle 3"/>
-          <p:cNvSpPr/>
-          <p:nvPr/>
-        </p:nvSpPr>
-        <p:spPr>
-          <a:xfrm>
-            <a:off x="640080" y="457200"/>
-            <a:ext cx="868680" cy="868680"/>
-          </a:xfrm>
-          <a:prstGeom prst="rect">
-            <a:avLst/>
-          </a:prstGeom>
-          <a:solidFill>
-            <a:srgbClr val="C08A1F"/>
-          </a:solidFill>
-          <a:ln>
-            <a:noFill/>
-          </a:ln>
-          <a:effectLst/>
-        </p:spPr>
-        <p:style>
-          <a:lnRef idx="1">
-            <a:schemeClr val="accent1"/>
-          </a:lnRef>
-          <a:fillRef idx="3">
-            <a:schemeClr val="accent1"/>
-          </a:fillRef>
-          <a:effectRef idx="2">
-            <a:schemeClr val="accent1"/>
-          </a:effectRef>
-          <a:fontRef idx="minor">
-            <a:schemeClr val="lt1"/>
-          </a:fontRef>
-        </p:style>
-        <p:txBody>
-          <a:bodyPr rtlCol="0" anchor="ctr"/>
-          <a:lstStyle/>
-          <a:p>
-            <a:pPr algn="ctr"/>
-          </a:p>
-        </p:txBody>
-      </p:sp>
-      <p:sp>
-        <p:nvSpPr>
-          <p:cNvPr id="5" name="TextBox 4"/>
-          <p:cNvSpPr txBox="1"/>
-          <p:nvPr/>
-        </p:nvSpPr>
-        <p:spPr>
-          <a:xfrm>
-            <a:off x="640080" y="457200"/>
-            <a:ext cx="868680" cy="868680"/>
-          </a:xfrm>
-          <a:prstGeom prst="rect">
-            <a:avLst/>
-          </a:prstGeom>
-          <a:noFill/>
-        </p:spPr>
-        <p:txBody>
-          <a:bodyPr wrap="square" anchor="ctr">
-            <a:spAutoFit/>
-          </a:bodyPr>
-          <a:lstStyle/>
-          <a:p>
-            <a:pPr algn="ctr"/>
-            <a:r>
-              <a:rPr sz="2600" b="1" i="0">
-                <a:solidFill>
-                  <a:srgbClr val="FFFFFF"/>
-                </a:solidFill>
-                <a:latin typeface="Century Gothic"/>
-              </a:rPr>
-              <a:t>3</a:t>
-            </a:r>
-          </a:p>
-        </p:txBody>
-      </p:sp>
       <p:pic>
         <p:nvPicPr>
-          <p:cNvPr id="6" name="Picture 5" descr="dashboard.png"/>
+          <p:cNvPr id="5" name="Picture 4" descr="dashboard.png"/>
           <p:cNvPicPr>
             <a:picLocks noChangeAspect="1"/>
           </p:cNvPicPr>
@@ -4149,7 +4000,7 @@
         </p:blipFill>
         <p:spPr>
           <a:xfrm>
-            <a:off x="6629400" y="2019807"/>
+            <a:off x="6629400" y="1928368"/>
             <a:ext cx="5120640" cy="3641344"/>
           </a:xfrm>
           <a:prstGeom prst="rect">
@@ -4177,204 +4028,20 @@
       <p:grpSpPr/>
       <p:sp>
         <p:nvSpPr>
-          <p:cNvPr id="2" name="Title 1"/>
-          <p:cNvSpPr>
-            <a:spLocks noGrp="1"/>
-          </p:cNvSpPr>
-          <p:nvPr>
-            <p:ph type="title"/>
-          </p:nvPr>
-        </p:nvSpPr>
-        <p:spPr>
-          <a:xfrm>
-            <a:off x="1691640" y="457200"/>
-            <a:ext cx="9875520" cy="868680"/>
-          </a:xfrm>
-        </p:spPr>
-        <p:txBody>
-          <a:bodyPr wrap="square" anchor="ctr"/>
-          <a:lstStyle/>
-          <a:p>
-            <a:pPr algn="l"/>
-            <a:r>
-              <a:rPr b="1" sz="2700">
-                <a:solidFill>
-                  <a:srgbClr val="C08A1F"/>
-                </a:solidFill>
-                <a:latin typeface="Century Gothic"/>
-              </a:rPr>
-              <a:t>The hardest part: a silent race</a:t>
-            </a:r>
-          </a:p>
-        </p:txBody>
-      </p:sp>
-      <p:sp>
-        <p:nvSpPr>
-          <p:cNvPr id="3" name="Content Placeholder 2"/>
-          <p:cNvSpPr>
-            <a:spLocks noGrp="1"/>
-          </p:cNvSpPr>
-          <p:nvPr>
-            <p:ph idx="1"/>
-          </p:nvPr>
-        </p:nvSpPr>
-        <p:spPr>
-          <a:xfrm>
-            <a:off x="658368" y="1600200"/>
-            <a:ext cx="10972800" cy="4663440"/>
-          </a:xfrm>
-        </p:spPr>
-        <p:txBody>
-          <a:bodyPr wrap="square">
-            <a:normAutofit/>
-          </a:bodyPr>
-          <a:lstStyle/>
-          <a:p>
-            <a:pPr>
-              <a:spcAft>
-                <a:spcPts val="600"/>
-              </a:spcAft>
-            </a:pPr>
-            <a:r>
-              <a:rPr sz="1500" b="0">
-                <a:solidFill>
-                  <a:srgbClr val="232A26"/>
-                </a:solidFill>
-                <a:latin typeface="Verdana"/>
-              </a:rPr>
-              <a:t>Every ten seconds the fog node hands its buffer over for flushing. What happens to a reading that arrives at that exact instant?</a:t>
-            </a:r>
-          </a:p>
-          <a:p>
-            <a:pPr>
-              <a:spcAft>
-                <a:spcPts val="600"/>
-              </a:spcAft>
-            </a:pPr>
-            <a:r>
-              <a:rPr sz="1500" b="0">
-                <a:solidFill>
-                  <a:srgbClr val="232A26"/>
-                </a:solidFill>
-                <a:latin typeface="Verdana"/>
-              </a:rPr>
-              <a:t>The problem:</a:t>
-            </a:r>
-          </a:p>
-          <a:p>
-            <a:pPr lvl="1">
-              <a:spcAft>
-                <a:spcPts val="600"/>
-              </a:spcAft>
-            </a:pPr>
-            <a:r>
-              <a:rPr sz="1300" b="0">
-                <a:solidFill>
-                  <a:srgbClr val="232A26"/>
-                </a:solidFill>
-                <a:latin typeface="Verdana"/>
-              </a:rPr>
-              <a:t>Sensor posts run on four parallel threads while a timer swaps the window buffer out for flushing. A reading landing mid-swap can be written into the retired buffer after the flush has already read it, and it simply vanishes.</a:t>
-            </a:r>
-          </a:p>
-          <a:p>
-            <a:pPr>
-              <a:spcAft>
-                <a:spcPts val="600"/>
-              </a:spcAft>
-            </a:pPr>
-            <a:r>
-              <a:rPr sz="1500" b="0">
-                <a:solidFill>
-                  <a:srgbClr val="232A26"/>
-                </a:solidFill>
-                <a:latin typeface="Verdana"/>
-              </a:rPr>
-              <a:t>Why it was hard:</a:t>
-            </a:r>
-          </a:p>
-          <a:p>
-            <a:pPr lvl="1">
-              <a:spcAft>
-                <a:spcPts val="600"/>
-              </a:spcAft>
-            </a:pPr>
-            <a:r>
-              <a:rPr sz="1300" b="0">
-                <a:solidFill>
-                  <a:srgbClr val="232A26"/>
-                </a:solidFill>
-                <a:latin typeface="Verdana"/>
-              </a:rPr>
-              <a:t>Nothing fails: no exception, no log line, just one number quietly missing from a summary. The timing hole is microseconds wide, so ordinary tests pass every time and the loss would only surface under real concurrent load.</a:t>
-            </a:r>
-          </a:p>
-          <a:p>
-            <a:pPr>
-              <a:spcAft>
-                <a:spcPts val="600"/>
-              </a:spcAft>
-            </a:pPr>
-            <a:r>
-              <a:rPr sz="1500" b="0">
-                <a:solidFill>
-                  <a:srgbClr val="232A26"/>
-                </a:solidFill>
-                <a:latin typeface="Verdana"/>
-              </a:rPr>
-              <a:t>The fix:</a:t>
-            </a:r>
-          </a:p>
-          <a:p>
-            <a:pPr lvl="1">
-              <a:spcAft>
-                <a:spcPts val="600"/>
-              </a:spcAft>
-            </a:pPr>
-            <a:r>
-              <a:rPr sz="1300" b="0">
-                <a:solidFill>
-                  <a:srgbClr val="232A26"/>
-                </a:solidFill>
-                <a:latin typeface="Verdana"/>
-              </a:rPr>
-              <a:t>Each buffer became a fenced generation. The flush closes the fence, waits for writers already inside to finish, then reads. A writer arriving after the fence is turned away and retries into the fresh buffer instead.</a:t>
-            </a:r>
-          </a:p>
-          <a:p>
-            <a:pPr>
-              <a:spcAft>
-                <a:spcPts val="600"/>
-              </a:spcAft>
-            </a:pPr>
-            <a:r>
-              <a:rPr sz="1500" b="0">
-                <a:solidFill>
-                  <a:srgbClr val="232A26"/>
-                </a:solidFill>
-                <a:latin typeface="Verdana"/>
-              </a:rPr>
-              <a:t>The ingest path stays lock-free; every reading now lands in exactly one window, guaranteed by the fence rather than a global lock.</a:t>
-            </a:r>
-          </a:p>
-        </p:txBody>
-      </p:sp>
-      <p:sp>
-        <p:nvSpPr>
           <p:cNvPr id="4" name="Rectangle 3"/>
           <p:cNvSpPr/>
           <p:nvPr/>
         </p:nvSpPr>
         <p:spPr>
           <a:xfrm>
-            <a:off x="640080" y="457200"/>
-            <a:ext cx="868680" cy="868680"/>
+            <a:off x="0" y="0"/>
+            <a:ext cx="12191695" cy="1051560"/>
           </a:xfrm>
           <a:prstGeom prst="rect">
             <a:avLst/>
           </a:prstGeom>
           <a:solidFill>
-            <a:srgbClr val="C08A1F"/>
+            <a:srgbClr val="1F7A8C"/>
           </a:solidFill>
           <a:ln>
             <a:noFill/>
@@ -4405,35 +4072,184 @@
       </p:sp>
       <p:sp>
         <p:nvSpPr>
-          <p:cNvPr id="5" name="TextBox 4"/>
-          <p:cNvSpPr txBox="1"/>
-          <p:nvPr/>
+          <p:cNvPr id="2" name="Title 1"/>
+          <p:cNvSpPr>
+            <a:spLocks noGrp="1"/>
+          </p:cNvSpPr>
+          <p:nvPr>
+            <p:ph type="title"/>
+          </p:nvPr>
         </p:nvSpPr>
         <p:spPr>
           <a:xfrm>
-            <a:off x="640080" y="457200"/>
-            <a:ext cx="868680" cy="868680"/>
+            <a:off x="640080" y="0"/>
+            <a:ext cx="10972800" cy="1051560"/>
           </a:xfrm>
-          <a:prstGeom prst="rect">
-            <a:avLst/>
-          </a:prstGeom>
-          <a:noFill/>
         </p:spPr>
         <p:txBody>
-          <a:bodyPr wrap="square" anchor="ctr">
-            <a:spAutoFit/>
+          <a:bodyPr wrap="square" anchor="ctr"/>
+          <a:lstStyle/>
+          <a:p>
+            <a:pPr algn="l"/>
+            <a:r>
+              <a:rPr b="1" sz="2400">
+                <a:solidFill>
+                  <a:srgbClr val="FFFFFF"/>
+                </a:solidFill>
+                <a:latin typeface="Calibri"/>
+              </a:rPr>
+              <a:t>The hardest part: a silent race</a:t>
+            </a:r>
+          </a:p>
+        </p:txBody>
+      </p:sp>
+      <p:sp>
+        <p:nvSpPr>
+          <p:cNvPr id="3" name="Content Placeholder 2"/>
+          <p:cNvSpPr>
+            <a:spLocks noGrp="1"/>
+          </p:cNvSpPr>
+          <p:nvPr>
+            <p:ph idx="1"/>
+          </p:nvPr>
+        </p:nvSpPr>
+        <p:spPr>
+          <a:xfrm>
+            <a:off x="658368" y="1371600"/>
+            <a:ext cx="10972800" cy="5029200"/>
+          </a:xfrm>
+        </p:spPr>
+        <p:txBody>
+          <a:bodyPr wrap="square">
+            <a:normAutofit/>
           </a:bodyPr>
           <a:lstStyle/>
           <a:p>
-            <a:pPr algn="ctr"/>
-            <a:r>
-              <a:rPr sz="2600" b="1" i="0">
-                <a:solidFill>
-                  <a:srgbClr val="FFFFFF"/>
-                </a:solidFill>
-                <a:latin typeface="Century Gothic"/>
+            <a:pPr>
+              <a:spcAft>
+                <a:spcPts val="600"/>
+              </a:spcAft>
+            </a:pPr>
+            <a:r>
+              <a:rPr sz="1500" b="0">
+                <a:solidFill>
+                  <a:srgbClr val="232A26"/>
+                </a:solidFill>
+                <a:latin typeface="Cambria"/>
               </a:rPr>
-              <a:t>4</a:t>
+              <a:t>Every ten seconds the fog node hands its buffer over for flushing. What happens to a reading that arrives at that exact instant?</a:t>
+            </a:r>
+          </a:p>
+          <a:p>
+            <a:pPr>
+              <a:spcAft>
+                <a:spcPts val="600"/>
+              </a:spcAft>
+            </a:pPr>
+            <a:r>
+              <a:rPr sz="1500" b="0">
+                <a:solidFill>
+                  <a:srgbClr val="232A26"/>
+                </a:solidFill>
+                <a:latin typeface="Cambria"/>
+              </a:rPr>
+              <a:t>The problem:</a:t>
+            </a:r>
+          </a:p>
+          <a:p>
+            <a:pPr lvl="1">
+              <a:spcAft>
+                <a:spcPts val="600"/>
+              </a:spcAft>
+            </a:pPr>
+            <a:r>
+              <a:rPr sz="1300" b="0">
+                <a:solidFill>
+                  <a:srgbClr val="232A26"/>
+                </a:solidFill>
+                <a:latin typeface="Cambria"/>
+              </a:rPr>
+              <a:t>Sensor posts run on four parallel threads while a timer swaps the window buffer out for flushing. A reading landing mid-swap can be written into the retired buffer after the flush has already read it, and it simply vanishes.</a:t>
+            </a:r>
+          </a:p>
+          <a:p>
+            <a:pPr>
+              <a:spcAft>
+                <a:spcPts val="600"/>
+              </a:spcAft>
+            </a:pPr>
+            <a:r>
+              <a:rPr sz="1500" b="0">
+                <a:solidFill>
+                  <a:srgbClr val="232A26"/>
+                </a:solidFill>
+                <a:latin typeface="Cambria"/>
+              </a:rPr>
+              <a:t>Why it was hard:</a:t>
+            </a:r>
+          </a:p>
+          <a:p>
+            <a:pPr lvl="1">
+              <a:spcAft>
+                <a:spcPts val="600"/>
+              </a:spcAft>
+            </a:pPr>
+            <a:r>
+              <a:rPr sz="1300" b="0">
+                <a:solidFill>
+                  <a:srgbClr val="232A26"/>
+                </a:solidFill>
+                <a:latin typeface="Cambria"/>
+              </a:rPr>
+              <a:t>Nothing fails: no exception, no log line, just one number quietly missing from a summary. The timing hole is microseconds wide, so ordinary tests pass every time and the loss would only surface under real concurrent load.</a:t>
+            </a:r>
+          </a:p>
+          <a:p>
+            <a:pPr>
+              <a:spcAft>
+                <a:spcPts val="600"/>
+              </a:spcAft>
+            </a:pPr>
+            <a:r>
+              <a:rPr sz="1500" b="0">
+                <a:solidFill>
+                  <a:srgbClr val="232A26"/>
+                </a:solidFill>
+                <a:latin typeface="Cambria"/>
+              </a:rPr>
+              <a:t>The fix:</a:t>
+            </a:r>
+          </a:p>
+          <a:p>
+            <a:pPr lvl="1">
+              <a:spcAft>
+                <a:spcPts val="600"/>
+              </a:spcAft>
+            </a:pPr>
+            <a:r>
+              <a:rPr sz="1300" b="0">
+                <a:solidFill>
+                  <a:srgbClr val="232A26"/>
+                </a:solidFill>
+                <a:latin typeface="Cambria"/>
+              </a:rPr>
+              <a:t>Each buffer became a fenced generation. The flush closes the fence, waits for writers already inside to finish, then reads. A writer arriving after the fence is turned away and retries into the fresh buffer instead.</a:t>
+            </a:r>
+          </a:p>
+          <a:p>
+            <a:pPr>
+              <a:spcAft>
+                <a:spcPts val="600"/>
+              </a:spcAft>
+            </a:pPr>
+            <a:r>
+              <a:rPr sz="1500" b="0">
+                <a:solidFill>
+                  <a:srgbClr val="232A26"/>
+                </a:solidFill>
+                <a:latin typeface="Cambria"/>
+              </a:rPr>
+              <a:t>The ingest path stays lock-free; every reading now lands in exactly one window, guaranteed by the fence rather than a global lock.</a:t>
             </a:r>
           </a:p>
         </p:txBody>
@@ -4458,140 +4274,20 @@
       <p:grpSpPr/>
       <p:sp>
         <p:nvSpPr>
-          <p:cNvPr id="2" name="Title 1"/>
-          <p:cNvSpPr>
-            <a:spLocks noGrp="1"/>
-          </p:cNvSpPr>
-          <p:nvPr>
-            <p:ph type="title"/>
-          </p:nvPr>
-        </p:nvSpPr>
-        <p:spPr>
-          <a:xfrm>
-            <a:off x="1691640" y="457200"/>
-            <a:ext cx="9875520" cy="868680"/>
-          </a:xfrm>
-        </p:spPr>
-        <p:txBody>
-          <a:bodyPr wrap="square" anchor="ctr"/>
-          <a:lstStyle/>
-          <a:p>
-            <a:pPr algn="l"/>
-            <a:r>
-              <a:rPr b="1" sz="2700">
-                <a:solidFill>
-                  <a:srgbClr val="C08A1F"/>
-                </a:solidFill>
-                <a:latin typeface="Century Gothic"/>
-              </a:rPr>
-              <a:t>Three things to take away</a:t>
-            </a:r>
-          </a:p>
-        </p:txBody>
-      </p:sp>
-      <p:sp>
-        <p:nvSpPr>
-          <p:cNvPr id="3" name="Content Placeholder 2"/>
-          <p:cNvSpPr>
-            <a:spLocks noGrp="1"/>
-          </p:cNvSpPr>
-          <p:nvPr>
-            <p:ph idx="1"/>
-          </p:nvPr>
-        </p:nvSpPr>
-        <p:spPr>
-          <a:xfrm>
-            <a:off x="658368" y="1600200"/>
-            <a:ext cx="10972800" cy="4663440"/>
-          </a:xfrm>
-        </p:spPr>
-        <p:txBody>
-          <a:bodyPr wrap="square">
-            <a:normAutofit/>
-          </a:bodyPr>
-          <a:lstStyle/>
-          <a:p>
-            <a:pPr>
-              <a:spcAft>
-                <a:spcPts val="900"/>
-              </a:spcAft>
-            </a:pPr>
-            <a:r>
-              <a:rPr sz="1700" b="0">
-                <a:solidFill>
-                  <a:srgbClr val="232A26"/>
-                </a:solidFill>
-                <a:latin typeface="Verdana"/>
-              </a:rPr>
-              <a:t>Alerts are computed beside the sensors: ten seconds from street reading to raised incident, and only compact summaries ever leave the edge.</a:t>
-            </a:r>
-          </a:p>
-          <a:p>
-            <a:pPr>
-              <a:spcAft>
-                <a:spcPts val="900"/>
-              </a:spcAft>
-            </a:pPr>
-            <a:r>
-              <a:rPr sz="1700" b="0">
-                <a:solidFill>
-                  <a:srgbClr val="232A26"/>
-                </a:solidFill>
-                <a:latin typeface="Verdana"/>
-              </a:rPr>
-              <a:t>The cloud side is serverless by construction: the same code runs against the local AWS emulator and real AWS, one scripted deployment step apart.</a:t>
-            </a:r>
-          </a:p>
-          <a:p>
-            <a:pPr>
-              <a:spcAft>
-                <a:spcPts val="900"/>
-              </a:spcAft>
-            </a:pPr>
-            <a:r>
-              <a:rPr sz="1700" b="0">
-                <a:solidFill>
-                  <a:srgbClr val="232A26"/>
-                </a:solidFill>
-                <a:latin typeface="Verdana"/>
-              </a:rPr>
-              <a:t>Correctness is proven, not assumed: 62 automated tests, an end-to-end pipeline check, a 2,000-message burst, and a fence for the bug that never showed itself.</a:t>
-            </a:r>
-          </a:p>
-          <a:p>
-            <a:pPr>
-              <a:spcAft>
-                <a:spcPts val="900"/>
-              </a:spcAft>
-            </a:pPr>
-            <a:r>
-              <a:rPr sz="1700" b="0">
-                <a:solidFill>
-                  <a:srgbClr val="232A26"/>
-                </a:solidFill>
-                <a:latin typeface="Verdana"/>
-              </a:rPr>
-              <a:t>Thank you. Questions?</a:t>
-            </a:r>
-          </a:p>
-        </p:txBody>
-      </p:sp>
-      <p:sp>
-        <p:nvSpPr>
           <p:cNvPr id="4" name="Rectangle 3"/>
           <p:cNvSpPr/>
           <p:nvPr/>
         </p:nvSpPr>
         <p:spPr>
           <a:xfrm>
-            <a:off x="640080" y="457200"/>
-            <a:ext cx="868680" cy="868680"/>
+            <a:off x="0" y="0"/>
+            <a:ext cx="12191695" cy="1051560"/>
           </a:xfrm>
           <a:prstGeom prst="rect">
             <a:avLst/>
           </a:prstGeom>
           <a:solidFill>
-            <a:srgbClr val="C08A1F"/>
+            <a:srgbClr val="1F7A8C"/>
           </a:solidFill>
           <a:ln>
             <a:noFill/>
@@ -4622,35 +4318,120 @@
       </p:sp>
       <p:sp>
         <p:nvSpPr>
-          <p:cNvPr id="5" name="TextBox 4"/>
-          <p:cNvSpPr txBox="1"/>
-          <p:nvPr/>
+          <p:cNvPr id="2" name="Title 1"/>
+          <p:cNvSpPr>
+            <a:spLocks noGrp="1"/>
+          </p:cNvSpPr>
+          <p:nvPr>
+            <p:ph type="title"/>
+          </p:nvPr>
         </p:nvSpPr>
         <p:spPr>
           <a:xfrm>
-            <a:off x="640080" y="457200"/>
-            <a:ext cx="868680" cy="868680"/>
+            <a:off x="640080" y="0"/>
+            <a:ext cx="10972800" cy="1051560"/>
           </a:xfrm>
-          <a:prstGeom prst="rect">
-            <a:avLst/>
-          </a:prstGeom>
-          <a:noFill/>
         </p:spPr>
         <p:txBody>
-          <a:bodyPr wrap="square" anchor="ctr">
-            <a:spAutoFit/>
+          <a:bodyPr wrap="square" anchor="ctr"/>
+          <a:lstStyle/>
+          <a:p>
+            <a:pPr algn="l"/>
+            <a:r>
+              <a:rPr b="1" sz="2400">
+                <a:solidFill>
+                  <a:srgbClr val="FFFFFF"/>
+                </a:solidFill>
+                <a:latin typeface="Calibri"/>
+              </a:rPr>
+              <a:t>Three things to take away</a:t>
+            </a:r>
+          </a:p>
+        </p:txBody>
+      </p:sp>
+      <p:sp>
+        <p:nvSpPr>
+          <p:cNvPr id="3" name="Content Placeholder 2"/>
+          <p:cNvSpPr>
+            <a:spLocks noGrp="1"/>
+          </p:cNvSpPr>
+          <p:nvPr>
+            <p:ph idx="1"/>
+          </p:nvPr>
+        </p:nvSpPr>
+        <p:spPr>
+          <a:xfrm>
+            <a:off x="658368" y="1371600"/>
+            <a:ext cx="10972800" cy="5029200"/>
+          </a:xfrm>
+        </p:spPr>
+        <p:txBody>
+          <a:bodyPr wrap="square">
+            <a:normAutofit/>
           </a:bodyPr>
           <a:lstStyle/>
           <a:p>
-            <a:pPr algn="ctr"/>
-            <a:r>
-              <a:rPr sz="2600" b="1" i="0">
-                <a:solidFill>
-                  <a:srgbClr val="FFFFFF"/>
-                </a:solidFill>
-                <a:latin typeface="Century Gothic"/>
+            <a:pPr>
+              <a:spcAft>
+                <a:spcPts val="900"/>
+              </a:spcAft>
+            </a:pPr>
+            <a:r>
+              <a:rPr sz="1700" b="0">
+                <a:solidFill>
+                  <a:srgbClr val="232A26"/>
+                </a:solidFill>
+                <a:latin typeface="Cambria"/>
               </a:rPr>
-              <a:t>5</a:t>
+              <a:t>Alerts are computed beside the sensors: ten seconds from street reading to raised incident, and only compact summaries ever leave the edge.</a:t>
+            </a:r>
+          </a:p>
+          <a:p>
+            <a:pPr>
+              <a:spcAft>
+                <a:spcPts val="900"/>
+              </a:spcAft>
+            </a:pPr>
+            <a:r>
+              <a:rPr sz="1700" b="0">
+                <a:solidFill>
+                  <a:srgbClr val="232A26"/>
+                </a:solidFill>
+                <a:latin typeface="Cambria"/>
+              </a:rPr>
+              <a:t>The cloud side is serverless by construction: the same code runs against the local AWS emulator and real AWS, one scripted deployment step apart.</a:t>
+            </a:r>
+          </a:p>
+          <a:p>
+            <a:pPr>
+              <a:spcAft>
+                <a:spcPts val="900"/>
+              </a:spcAft>
+            </a:pPr>
+            <a:r>
+              <a:rPr sz="1700" b="0">
+                <a:solidFill>
+                  <a:srgbClr val="232A26"/>
+                </a:solidFill>
+                <a:latin typeface="Cambria"/>
+              </a:rPr>
+              <a:t>Correctness is proven, not assumed: 62 automated tests, an end-to-end pipeline check, a 2,000-message burst, and a fence for the bug that never showed itself.</a:t>
+            </a:r>
+          </a:p>
+          <a:p>
+            <a:pPr>
+              <a:spcAft>
+                <a:spcPts val="900"/>
+              </a:spcAft>
+            </a:pPr>
+            <a:r>
+              <a:rPr sz="1700" b="0">
+                <a:solidFill>
+                  <a:srgbClr val="232A26"/>
+                </a:solidFill>
+                <a:latin typeface="Cambria"/>
+              </a:rPr>
+              <a:t>Thank you. Questions?</a:t>
             </a:r>
           </a:p>
         </p:txBody>

</xml_diff>

<commit_message>
Move Hassan's project 04 deck to unique sidebarL layout (was band, shared with Nithin's deck); now no deck shares its layout with his
</commit_message>
<xml_diff>
--- a/ppt/X25100963_smart-city-monitoring.pptx
+++ b/ppt/X25100963_smart-city-monitoring.pptx
@@ -3305,7 +3305,7 @@
         <p:spPr>
           <a:xfrm>
             <a:off x="0" y="0"/>
-            <a:ext cx="12191695" cy="1051560"/>
+            <a:ext cx="1051560" cy="6858000"/>
           </a:xfrm>
           <a:prstGeom prst="rect">
             <a:avLst/>
@@ -3352,19 +3352,19 @@
         </p:nvSpPr>
         <p:spPr>
           <a:xfrm>
-            <a:off x="640080" y="0"/>
-            <a:ext cx="10972800" cy="1051560"/>
-          </a:xfrm>
-        </p:spPr>
-        <p:txBody>
-          <a:bodyPr wrap="square" anchor="ctr"/>
+            <a:off x="1371600" y="457200"/>
+            <a:ext cx="9311335" cy="868680"/>
+          </a:xfrm>
+        </p:spPr>
+        <p:txBody>
+          <a:bodyPr wrap="square" anchor="t"/>
           <a:lstStyle/>
           <a:p>
             <a:pPr algn="l"/>
             <a:r>
-              <a:rPr b="1" sz="2400">
-                <a:solidFill>
-                  <a:srgbClr val="FFFFFF"/>
+              <a:rPr b="1" sz="2700">
+                <a:solidFill>
+                  <a:srgbClr val="1F7A8C"/>
                 </a:solidFill>
                 <a:latin typeface="Calibri"/>
               </a:rPr>
@@ -3385,8 +3385,8 @@
         </p:nvSpPr>
         <p:spPr>
           <a:xfrm>
-            <a:off x="658368" y="1371600"/>
-            <a:ext cx="10972800" cy="5029200"/>
+            <a:off x="1389888" y="1508760"/>
+            <a:ext cx="9402775" cy="4846320"/>
           </a:xfrm>
         </p:spPr>
         <p:txBody>
@@ -3505,6 +3505,85 @@
               </a:rPr>
               <a:t>Each of ten street sensors reports one reading every 2 to 5 seconds continuously, and no manual process keeps up with that.</a:t>
             </a:r>
+          </a:p>
+        </p:txBody>
+      </p:sp>
+      <p:sp>
+        <p:nvSpPr>
+          <p:cNvPr id="5" name="TextBox 4"/>
+          <p:cNvSpPr txBox="1"/>
+          <p:nvPr/>
+        </p:nvSpPr>
+        <p:spPr>
+          <a:xfrm>
+            <a:off x="0" y="320040"/>
+            <a:ext cx="1051560" cy="914400"/>
+          </a:xfrm>
+          <a:prstGeom prst="rect">
+            <a:avLst/>
+          </a:prstGeom>
+          <a:noFill/>
+        </p:spPr>
+        <p:txBody>
+          <a:bodyPr wrap="square" anchor="t">
+            <a:spAutoFit/>
+          </a:bodyPr>
+          <a:lstStyle/>
+          <a:p>
+            <a:pPr algn="ctr"/>
+            <a:r>
+              <a:rPr sz="2600" b="1" i="0">
+                <a:solidFill>
+                  <a:srgbClr val="FFFFFF"/>
+                </a:solidFill>
+                <a:latin typeface="Calibri"/>
+              </a:rPr>
+              <a:t>1</a:t>
+            </a:r>
+          </a:p>
+        </p:txBody>
+      </p:sp>
+      <p:sp>
+        <p:nvSpPr>
+          <p:cNvPr id="6" name="Rectangle 5"/>
+          <p:cNvSpPr/>
+          <p:nvPr/>
+        </p:nvSpPr>
+        <p:spPr>
+          <a:xfrm>
+            <a:off x="1389888" y="1325880"/>
+            <a:ext cx="2926080" cy="36576"/>
+          </a:xfrm>
+          <a:prstGeom prst="rect">
+            <a:avLst/>
+          </a:prstGeom>
+          <a:solidFill>
+            <a:srgbClr val="1F7A8C"/>
+          </a:solidFill>
+          <a:ln>
+            <a:noFill/>
+          </a:ln>
+          <a:effectLst/>
+        </p:spPr>
+        <p:style>
+          <a:lnRef idx="1">
+            <a:schemeClr val="accent1"/>
+          </a:lnRef>
+          <a:fillRef idx="3">
+            <a:schemeClr val="accent1"/>
+          </a:fillRef>
+          <a:effectRef idx="2">
+            <a:schemeClr val="accent1"/>
+          </a:effectRef>
+          <a:fontRef idx="minor">
+            <a:schemeClr val="lt1"/>
+          </a:fontRef>
+        </p:style>
+        <p:txBody>
+          <a:bodyPr rtlCol="0" anchor="ctr"/>
+          <a:lstStyle/>
+          <a:p>
+            <a:pPr algn="ctr"/>
           </a:p>
         </p:txBody>
       </p:sp>
@@ -3535,7 +3614,7 @@
         <p:spPr>
           <a:xfrm>
             <a:off x="0" y="0"/>
-            <a:ext cx="12191695" cy="1051560"/>
+            <a:ext cx="1051560" cy="6858000"/>
           </a:xfrm>
           <a:prstGeom prst="rect">
             <a:avLst/>
@@ -3582,19 +3661,19 @@
         </p:nvSpPr>
         <p:spPr>
           <a:xfrm>
-            <a:off x="640080" y="0"/>
-            <a:ext cx="10972800" cy="1051560"/>
-          </a:xfrm>
-        </p:spPr>
-        <p:txBody>
-          <a:bodyPr wrap="square" anchor="ctr"/>
+            <a:off x="1371600" y="457200"/>
+            <a:ext cx="9311335" cy="868680"/>
+          </a:xfrm>
+        </p:spPr>
+        <p:txBody>
+          <a:bodyPr wrap="square" anchor="t"/>
           <a:lstStyle/>
           <a:p>
             <a:pPr algn="l"/>
             <a:r>
-              <a:rPr b="1" sz="2400">
-                <a:solidFill>
-                  <a:srgbClr val="FFFFFF"/>
+              <a:rPr b="1" sz="2700">
+                <a:solidFill>
+                  <a:srgbClr val="1F7A8C"/>
                 </a:solidFill>
                 <a:latin typeface="Calibri"/>
               </a:rPr>
@@ -3615,8 +3694,8 @@
         </p:nvSpPr>
         <p:spPr>
           <a:xfrm>
-            <a:off x="658368" y="1371600"/>
-            <a:ext cx="10972800" cy="5029200"/>
+            <a:off x="1389888" y="1508760"/>
+            <a:ext cx="9402775" cy="4846320"/>
           </a:xfrm>
         </p:spPr>
         <p:txBody>
@@ -3767,6 +3846,85 @@
               </a:rPr>
               <a:t>Each zone and metric leaves the street as one compact summary every ten seconds, alerts already attached.</a:t>
             </a:r>
+          </a:p>
+        </p:txBody>
+      </p:sp>
+      <p:sp>
+        <p:nvSpPr>
+          <p:cNvPr id="5" name="TextBox 4"/>
+          <p:cNvSpPr txBox="1"/>
+          <p:nvPr/>
+        </p:nvSpPr>
+        <p:spPr>
+          <a:xfrm>
+            <a:off x="0" y="320040"/>
+            <a:ext cx="1051560" cy="914400"/>
+          </a:xfrm>
+          <a:prstGeom prst="rect">
+            <a:avLst/>
+          </a:prstGeom>
+          <a:noFill/>
+        </p:spPr>
+        <p:txBody>
+          <a:bodyPr wrap="square" anchor="t">
+            <a:spAutoFit/>
+          </a:bodyPr>
+          <a:lstStyle/>
+          <a:p>
+            <a:pPr algn="ctr"/>
+            <a:r>
+              <a:rPr sz="2600" b="1" i="0">
+                <a:solidFill>
+                  <a:srgbClr val="FFFFFF"/>
+                </a:solidFill>
+                <a:latin typeface="Calibri"/>
+              </a:rPr>
+              <a:t>2</a:t>
+            </a:r>
+          </a:p>
+        </p:txBody>
+      </p:sp>
+      <p:sp>
+        <p:nvSpPr>
+          <p:cNvPr id="6" name="Rectangle 5"/>
+          <p:cNvSpPr/>
+          <p:nvPr/>
+        </p:nvSpPr>
+        <p:spPr>
+          <a:xfrm>
+            <a:off x="1389888" y="1325880"/>
+            <a:ext cx="2926080" cy="36576"/>
+          </a:xfrm>
+          <a:prstGeom prst="rect">
+            <a:avLst/>
+          </a:prstGeom>
+          <a:solidFill>
+            <a:srgbClr val="1F7A8C"/>
+          </a:solidFill>
+          <a:ln>
+            <a:noFill/>
+          </a:ln>
+          <a:effectLst/>
+        </p:spPr>
+        <p:style>
+          <a:lnRef idx="1">
+            <a:schemeClr val="accent1"/>
+          </a:lnRef>
+          <a:fillRef idx="3">
+            <a:schemeClr val="accent1"/>
+          </a:fillRef>
+          <a:effectRef idx="2">
+            <a:schemeClr val="accent1"/>
+          </a:effectRef>
+          <a:fontRef idx="minor">
+            <a:schemeClr val="lt1"/>
+          </a:fontRef>
+        </p:style>
+        <p:txBody>
+          <a:bodyPr rtlCol="0" anchor="ctr"/>
+          <a:lstStyle/>
+          <a:p>
+            <a:pPr algn="ctr"/>
           </a:p>
         </p:txBody>
       </p:sp>
@@ -3797,7 +3955,7 @@
         <p:spPr>
           <a:xfrm>
             <a:off x="0" y="0"/>
-            <a:ext cx="12191695" cy="1051560"/>
+            <a:ext cx="1051560" cy="6858000"/>
           </a:xfrm>
           <a:prstGeom prst="rect">
             <a:avLst/>
@@ -3844,19 +4002,19 @@
         </p:nvSpPr>
         <p:spPr>
           <a:xfrm>
-            <a:off x="640080" y="0"/>
-            <a:ext cx="10972800" cy="1051560"/>
-          </a:xfrm>
-        </p:spPr>
-        <p:txBody>
-          <a:bodyPr wrap="square" anchor="ctr"/>
+            <a:off x="1371600" y="457200"/>
+            <a:ext cx="9311335" cy="868680"/>
+          </a:xfrm>
+        </p:spPr>
+        <p:txBody>
+          <a:bodyPr wrap="square" anchor="t"/>
           <a:lstStyle/>
           <a:p>
             <a:pPr algn="l"/>
             <a:r>
-              <a:rPr b="1" sz="2400">
-                <a:solidFill>
-                  <a:srgbClr val="FFFFFF"/>
+              <a:rPr b="1" sz="2700">
+                <a:solidFill>
+                  <a:srgbClr val="1F7A8C"/>
                 </a:solidFill>
                 <a:latin typeface="Calibri"/>
               </a:rPr>
@@ -3877,8 +4035,8 @@
         </p:nvSpPr>
         <p:spPr>
           <a:xfrm>
-            <a:off x="658368" y="1371600"/>
-            <a:ext cx="5760720" cy="4937760"/>
+            <a:off x="1389888" y="1508760"/>
+            <a:ext cx="5394960" cy="4754880"/>
           </a:xfrm>
         </p:spPr>
         <p:txBody>
@@ -3984,9 +4142,88 @@
           </a:p>
         </p:txBody>
       </p:sp>
+      <p:sp>
+        <p:nvSpPr>
+          <p:cNvPr id="5" name="TextBox 4"/>
+          <p:cNvSpPr txBox="1"/>
+          <p:nvPr/>
+        </p:nvSpPr>
+        <p:spPr>
+          <a:xfrm>
+            <a:off x="0" y="320040"/>
+            <a:ext cx="1051560" cy="914400"/>
+          </a:xfrm>
+          <a:prstGeom prst="rect">
+            <a:avLst/>
+          </a:prstGeom>
+          <a:noFill/>
+        </p:spPr>
+        <p:txBody>
+          <a:bodyPr wrap="square" anchor="t">
+            <a:spAutoFit/>
+          </a:bodyPr>
+          <a:lstStyle/>
+          <a:p>
+            <a:pPr algn="ctr"/>
+            <a:r>
+              <a:rPr sz="2600" b="1" i="0">
+                <a:solidFill>
+                  <a:srgbClr val="FFFFFF"/>
+                </a:solidFill>
+                <a:latin typeface="Calibri"/>
+              </a:rPr>
+              <a:t>3</a:t>
+            </a:r>
+          </a:p>
+        </p:txBody>
+      </p:sp>
+      <p:sp>
+        <p:nvSpPr>
+          <p:cNvPr id="6" name="Rectangle 5"/>
+          <p:cNvSpPr/>
+          <p:nvPr/>
+        </p:nvSpPr>
+        <p:spPr>
+          <a:xfrm>
+            <a:off x="1389888" y="1325880"/>
+            <a:ext cx="2926080" cy="36576"/>
+          </a:xfrm>
+          <a:prstGeom prst="rect">
+            <a:avLst/>
+          </a:prstGeom>
+          <a:solidFill>
+            <a:srgbClr val="1F7A8C"/>
+          </a:solidFill>
+          <a:ln>
+            <a:noFill/>
+          </a:ln>
+          <a:effectLst/>
+        </p:spPr>
+        <p:style>
+          <a:lnRef idx="1">
+            <a:schemeClr val="accent1"/>
+          </a:lnRef>
+          <a:fillRef idx="3">
+            <a:schemeClr val="accent1"/>
+          </a:fillRef>
+          <a:effectRef idx="2">
+            <a:schemeClr val="accent1"/>
+          </a:effectRef>
+          <a:fontRef idx="minor">
+            <a:schemeClr val="lt1"/>
+          </a:fontRef>
+        </p:style>
+        <p:txBody>
+          <a:bodyPr rtlCol="0" anchor="ctr"/>
+          <a:lstStyle/>
+          <a:p>
+            <a:pPr algn="ctr"/>
+          </a:p>
+        </p:txBody>
+      </p:sp>
       <p:pic>
         <p:nvPicPr>
-          <p:cNvPr id="5" name="Picture 4" descr="dashboard.png"/>
+          <p:cNvPr id="7" name="Picture 6" descr="dashboard.png"/>
           <p:cNvPicPr>
             <a:picLocks noChangeAspect="1"/>
           </p:cNvPicPr>
@@ -4000,8 +4237,8 @@
         </p:blipFill>
         <p:spPr>
           <a:xfrm>
-            <a:off x="6629400" y="1928368"/>
-            <a:ext cx="5120640" cy="3641344"/>
+            <a:off x="6858000" y="2201672"/>
+            <a:ext cx="4480560" cy="3186176"/>
           </a:xfrm>
           <a:prstGeom prst="rect">
             <a:avLst/>
@@ -4035,7 +4272,7 @@
         <p:spPr>
           <a:xfrm>
             <a:off x="0" y="0"/>
-            <a:ext cx="12191695" cy="1051560"/>
+            <a:ext cx="1051560" cy="6858000"/>
           </a:xfrm>
           <a:prstGeom prst="rect">
             <a:avLst/>
@@ -4082,19 +4319,19 @@
         </p:nvSpPr>
         <p:spPr>
           <a:xfrm>
-            <a:off x="640080" y="0"/>
-            <a:ext cx="10972800" cy="1051560"/>
-          </a:xfrm>
-        </p:spPr>
-        <p:txBody>
-          <a:bodyPr wrap="square" anchor="ctr"/>
+            <a:off x="1371600" y="457200"/>
+            <a:ext cx="9311335" cy="868680"/>
+          </a:xfrm>
+        </p:spPr>
+        <p:txBody>
+          <a:bodyPr wrap="square" anchor="t"/>
           <a:lstStyle/>
           <a:p>
             <a:pPr algn="l"/>
             <a:r>
-              <a:rPr b="1" sz="2400">
-                <a:solidFill>
-                  <a:srgbClr val="FFFFFF"/>
+              <a:rPr b="1" sz="2700">
+                <a:solidFill>
+                  <a:srgbClr val="1F7A8C"/>
                 </a:solidFill>
                 <a:latin typeface="Calibri"/>
               </a:rPr>
@@ -4115,8 +4352,8 @@
         </p:nvSpPr>
         <p:spPr>
           <a:xfrm>
-            <a:off x="658368" y="1371600"/>
-            <a:ext cx="10972800" cy="5029200"/>
+            <a:off x="1389888" y="1508760"/>
+            <a:ext cx="9402775" cy="4846320"/>
           </a:xfrm>
         </p:spPr>
         <p:txBody>
@@ -4251,6 +4488,85 @@
               </a:rPr>
               <a:t>The ingest path stays lock-free; every reading now lands in exactly one window, guaranteed by the fence rather than a global lock.</a:t>
             </a:r>
+          </a:p>
+        </p:txBody>
+      </p:sp>
+      <p:sp>
+        <p:nvSpPr>
+          <p:cNvPr id="5" name="TextBox 4"/>
+          <p:cNvSpPr txBox="1"/>
+          <p:nvPr/>
+        </p:nvSpPr>
+        <p:spPr>
+          <a:xfrm>
+            <a:off x="0" y="320040"/>
+            <a:ext cx="1051560" cy="914400"/>
+          </a:xfrm>
+          <a:prstGeom prst="rect">
+            <a:avLst/>
+          </a:prstGeom>
+          <a:noFill/>
+        </p:spPr>
+        <p:txBody>
+          <a:bodyPr wrap="square" anchor="t">
+            <a:spAutoFit/>
+          </a:bodyPr>
+          <a:lstStyle/>
+          <a:p>
+            <a:pPr algn="ctr"/>
+            <a:r>
+              <a:rPr sz="2600" b="1" i="0">
+                <a:solidFill>
+                  <a:srgbClr val="FFFFFF"/>
+                </a:solidFill>
+                <a:latin typeface="Calibri"/>
+              </a:rPr>
+              <a:t>4</a:t>
+            </a:r>
+          </a:p>
+        </p:txBody>
+      </p:sp>
+      <p:sp>
+        <p:nvSpPr>
+          <p:cNvPr id="6" name="Rectangle 5"/>
+          <p:cNvSpPr/>
+          <p:nvPr/>
+        </p:nvSpPr>
+        <p:spPr>
+          <a:xfrm>
+            <a:off x="1389888" y="1325880"/>
+            <a:ext cx="2926080" cy="36576"/>
+          </a:xfrm>
+          <a:prstGeom prst="rect">
+            <a:avLst/>
+          </a:prstGeom>
+          <a:solidFill>
+            <a:srgbClr val="1F7A8C"/>
+          </a:solidFill>
+          <a:ln>
+            <a:noFill/>
+          </a:ln>
+          <a:effectLst/>
+        </p:spPr>
+        <p:style>
+          <a:lnRef idx="1">
+            <a:schemeClr val="accent1"/>
+          </a:lnRef>
+          <a:fillRef idx="3">
+            <a:schemeClr val="accent1"/>
+          </a:fillRef>
+          <a:effectRef idx="2">
+            <a:schemeClr val="accent1"/>
+          </a:effectRef>
+          <a:fontRef idx="minor">
+            <a:schemeClr val="lt1"/>
+          </a:fontRef>
+        </p:style>
+        <p:txBody>
+          <a:bodyPr rtlCol="0" anchor="ctr"/>
+          <a:lstStyle/>
+          <a:p>
+            <a:pPr algn="ctr"/>
           </a:p>
         </p:txBody>
       </p:sp>
@@ -4281,7 +4597,7 @@
         <p:spPr>
           <a:xfrm>
             <a:off x="0" y="0"/>
-            <a:ext cx="12191695" cy="1051560"/>
+            <a:ext cx="1051560" cy="6858000"/>
           </a:xfrm>
           <a:prstGeom prst="rect">
             <a:avLst/>
@@ -4328,19 +4644,19 @@
         </p:nvSpPr>
         <p:spPr>
           <a:xfrm>
-            <a:off x="640080" y="0"/>
-            <a:ext cx="10972800" cy="1051560"/>
-          </a:xfrm>
-        </p:spPr>
-        <p:txBody>
-          <a:bodyPr wrap="square" anchor="ctr"/>
+            <a:off x="1371600" y="457200"/>
+            <a:ext cx="9311335" cy="868680"/>
+          </a:xfrm>
+        </p:spPr>
+        <p:txBody>
+          <a:bodyPr wrap="square" anchor="t"/>
           <a:lstStyle/>
           <a:p>
             <a:pPr algn="l"/>
             <a:r>
-              <a:rPr b="1" sz="2400">
-                <a:solidFill>
-                  <a:srgbClr val="FFFFFF"/>
+              <a:rPr b="1" sz="2700">
+                <a:solidFill>
+                  <a:srgbClr val="1F7A8C"/>
                 </a:solidFill>
                 <a:latin typeface="Calibri"/>
               </a:rPr>
@@ -4361,8 +4677,8 @@
         </p:nvSpPr>
         <p:spPr>
           <a:xfrm>
-            <a:off x="658368" y="1371600"/>
-            <a:ext cx="10972800" cy="5029200"/>
+            <a:off x="1389888" y="1508760"/>
+            <a:ext cx="9402775" cy="4846320"/>
           </a:xfrm>
         </p:spPr>
         <p:txBody>
@@ -4433,6 +4749,85 @@
               </a:rPr>
               <a:t>Thank you. Questions?</a:t>
             </a:r>
+          </a:p>
+        </p:txBody>
+      </p:sp>
+      <p:sp>
+        <p:nvSpPr>
+          <p:cNvPr id="5" name="TextBox 4"/>
+          <p:cNvSpPr txBox="1"/>
+          <p:nvPr/>
+        </p:nvSpPr>
+        <p:spPr>
+          <a:xfrm>
+            <a:off x="0" y="320040"/>
+            <a:ext cx="1051560" cy="914400"/>
+          </a:xfrm>
+          <a:prstGeom prst="rect">
+            <a:avLst/>
+          </a:prstGeom>
+          <a:noFill/>
+        </p:spPr>
+        <p:txBody>
+          <a:bodyPr wrap="square" anchor="t">
+            <a:spAutoFit/>
+          </a:bodyPr>
+          <a:lstStyle/>
+          <a:p>
+            <a:pPr algn="ctr"/>
+            <a:r>
+              <a:rPr sz="2600" b="1" i="0">
+                <a:solidFill>
+                  <a:srgbClr val="FFFFFF"/>
+                </a:solidFill>
+                <a:latin typeface="Calibri"/>
+              </a:rPr>
+              <a:t>5</a:t>
+            </a:r>
+          </a:p>
+        </p:txBody>
+      </p:sp>
+      <p:sp>
+        <p:nvSpPr>
+          <p:cNvPr id="6" name="Rectangle 5"/>
+          <p:cNvSpPr/>
+          <p:nvPr/>
+        </p:nvSpPr>
+        <p:spPr>
+          <a:xfrm>
+            <a:off x="1389888" y="1325880"/>
+            <a:ext cx="2926080" cy="36576"/>
+          </a:xfrm>
+          <a:prstGeom prst="rect">
+            <a:avLst/>
+          </a:prstGeom>
+          <a:solidFill>
+            <a:srgbClr val="1F7A8C"/>
+          </a:solidFill>
+          <a:ln>
+            <a:noFill/>
+          </a:ln>
+          <a:effectLst/>
+        </p:spPr>
+        <p:style>
+          <a:lnRef idx="1">
+            <a:schemeClr val="accent1"/>
+          </a:lnRef>
+          <a:fillRef idx="3">
+            <a:schemeClr val="accent1"/>
+          </a:fillRef>
+          <a:effectRef idx="2">
+            <a:schemeClr val="accent1"/>
+          </a:effectRef>
+          <a:fontRef idx="minor">
+            <a:schemeClr val="lt1"/>
+          </a:fontRef>
+        </p:style>
+        <p:txBody>
+          <a:bodyPr rtlCol="0" anchor="ctr"/>
+          <a:lstStyle/>
+          <a:p>
+            <a:pPr algn="ctr"/>
           </a:p>
         </p:txBody>
       </p:sp>

</xml_diff>

<commit_message>
Remove the slide-number from Hassan's deck sidebar (sidebarL layout, used only by his deck)
</commit_message>
<xml_diff>
--- a/ppt/X25100963_smart-city-monitoring.pptx
+++ b/ppt/X25100963_smart-city-monitoring.pptx
@@ -3510,42 +3510,7 @@
       </p:sp>
       <p:sp>
         <p:nvSpPr>
-          <p:cNvPr id="5" name="TextBox 4"/>
-          <p:cNvSpPr txBox="1"/>
-          <p:nvPr/>
-        </p:nvSpPr>
-        <p:spPr>
-          <a:xfrm>
-            <a:off x="0" y="320040"/>
-            <a:ext cx="1051560" cy="914400"/>
-          </a:xfrm>
-          <a:prstGeom prst="rect">
-            <a:avLst/>
-          </a:prstGeom>
-          <a:noFill/>
-        </p:spPr>
-        <p:txBody>
-          <a:bodyPr wrap="square" anchor="t">
-            <a:spAutoFit/>
-          </a:bodyPr>
-          <a:lstStyle/>
-          <a:p>
-            <a:pPr algn="ctr"/>
-            <a:r>
-              <a:rPr sz="2600" b="1" i="0">
-                <a:solidFill>
-                  <a:srgbClr val="FFFFFF"/>
-                </a:solidFill>
-                <a:latin typeface="Calibri"/>
-              </a:rPr>
-              <a:t>1</a:t>
-            </a:r>
-          </a:p>
-        </p:txBody>
-      </p:sp>
-      <p:sp>
-        <p:nvSpPr>
-          <p:cNvPr id="6" name="Rectangle 5"/>
+          <p:cNvPr id="5" name="Rectangle 4"/>
           <p:cNvSpPr/>
           <p:nvPr/>
         </p:nvSpPr>
@@ -3851,42 +3816,7 @@
       </p:sp>
       <p:sp>
         <p:nvSpPr>
-          <p:cNvPr id="5" name="TextBox 4"/>
-          <p:cNvSpPr txBox="1"/>
-          <p:nvPr/>
-        </p:nvSpPr>
-        <p:spPr>
-          <a:xfrm>
-            <a:off x="0" y="320040"/>
-            <a:ext cx="1051560" cy="914400"/>
-          </a:xfrm>
-          <a:prstGeom prst="rect">
-            <a:avLst/>
-          </a:prstGeom>
-          <a:noFill/>
-        </p:spPr>
-        <p:txBody>
-          <a:bodyPr wrap="square" anchor="t">
-            <a:spAutoFit/>
-          </a:bodyPr>
-          <a:lstStyle/>
-          <a:p>
-            <a:pPr algn="ctr"/>
-            <a:r>
-              <a:rPr sz="2600" b="1" i="0">
-                <a:solidFill>
-                  <a:srgbClr val="FFFFFF"/>
-                </a:solidFill>
-                <a:latin typeface="Calibri"/>
-              </a:rPr>
-              <a:t>2</a:t>
-            </a:r>
-          </a:p>
-        </p:txBody>
-      </p:sp>
-      <p:sp>
-        <p:nvSpPr>
-          <p:cNvPr id="6" name="Rectangle 5"/>
+          <p:cNvPr id="5" name="Rectangle 4"/>
           <p:cNvSpPr/>
           <p:nvPr/>
         </p:nvSpPr>
@@ -4144,42 +4074,7 @@
       </p:sp>
       <p:sp>
         <p:nvSpPr>
-          <p:cNvPr id="5" name="TextBox 4"/>
-          <p:cNvSpPr txBox="1"/>
-          <p:nvPr/>
-        </p:nvSpPr>
-        <p:spPr>
-          <a:xfrm>
-            <a:off x="0" y="320040"/>
-            <a:ext cx="1051560" cy="914400"/>
-          </a:xfrm>
-          <a:prstGeom prst="rect">
-            <a:avLst/>
-          </a:prstGeom>
-          <a:noFill/>
-        </p:spPr>
-        <p:txBody>
-          <a:bodyPr wrap="square" anchor="t">
-            <a:spAutoFit/>
-          </a:bodyPr>
-          <a:lstStyle/>
-          <a:p>
-            <a:pPr algn="ctr"/>
-            <a:r>
-              <a:rPr sz="2600" b="1" i="0">
-                <a:solidFill>
-                  <a:srgbClr val="FFFFFF"/>
-                </a:solidFill>
-                <a:latin typeface="Calibri"/>
-              </a:rPr>
-              <a:t>3</a:t>
-            </a:r>
-          </a:p>
-        </p:txBody>
-      </p:sp>
-      <p:sp>
-        <p:nvSpPr>
-          <p:cNvPr id="6" name="Rectangle 5"/>
+          <p:cNvPr id="5" name="Rectangle 4"/>
           <p:cNvSpPr/>
           <p:nvPr/>
         </p:nvSpPr>
@@ -4223,7 +4118,7 @@
       </p:sp>
       <p:pic>
         <p:nvPicPr>
-          <p:cNvPr id="7" name="Picture 6" descr="dashboard.png"/>
+          <p:cNvPr id="6" name="Picture 5" descr="dashboard.png"/>
           <p:cNvPicPr>
             <a:picLocks noChangeAspect="1"/>
           </p:cNvPicPr>
@@ -4493,42 +4388,7 @@
       </p:sp>
       <p:sp>
         <p:nvSpPr>
-          <p:cNvPr id="5" name="TextBox 4"/>
-          <p:cNvSpPr txBox="1"/>
-          <p:nvPr/>
-        </p:nvSpPr>
-        <p:spPr>
-          <a:xfrm>
-            <a:off x="0" y="320040"/>
-            <a:ext cx="1051560" cy="914400"/>
-          </a:xfrm>
-          <a:prstGeom prst="rect">
-            <a:avLst/>
-          </a:prstGeom>
-          <a:noFill/>
-        </p:spPr>
-        <p:txBody>
-          <a:bodyPr wrap="square" anchor="t">
-            <a:spAutoFit/>
-          </a:bodyPr>
-          <a:lstStyle/>
-          <a:p>
-            <a:pPr algn="ctr"/>
-            <a:r>
-              <a:rPr sz="2600" b="1" i="0">
-                <a:solidFill>
-                  <a:srgbClr val="FFFFFF"/>
-                </a:solidFill>
-                <a:latin typeface="Calibri"/>
-              </a:rPr>
-              <a:t>4</a:t>
-            </a:r>
-          </a:p>
-        </p:txBody>
-      </p:sp>
-      <p:sp>
-        <p:nvSpPr>
-          <p:cNvPr id="6" name="Rectangle 5"/>
+          <p:cNvPr id="5" name="Rectangle 4"/>
           <p:cNvSpPr/>
           <p:nvPr/>
         </p:nvSpPr>
@@ -4754,42 +4614,7 @@
       </p:sp>
       <p:sp>
         <p:nvSpPr>
-          <p:cNvPr id="5" name="TextBox 4"/>
-          <p:cNvSpPr txBox="1"/>
-          <p:nvPr/>
-        </p:nvSpPr>
-        <p:spPr>
-          <a:xfrm>
-            <a:off x="0" y="320040"/>
-            <a:ext cx="1051560" cy="914400"/>
-          </a:xfrm>
-          <a:prstGeom prst="rect">
-            <a:avLst/>
-          </a:prstGeom>
-          <a:noFill/>
-        </p:spPr>
-        <p:txBody>
-          <a:bodyPr wrap="square" anchor="t">
-            <a:spAutoFit/>
-          </a:bodyPr>
-          <a:lstStyle/>
-          <a:p>
-            <a:pPr algn="ctr"/>
-            <a:r>
-              <a:rPr sz="2600" b="1" i="0">
-                <a:solidFill>
-                  <a:srgbClr val="FFFFFF"/>
-                </a:solidFill>
-                <a:latin typeface="Calibri"/>
-              </a:rPr>
-              <a:t>5</a:t>
-            </a:r>
-          </a:p>
-        </p:txBody>
-      </p:sp>
-      <p:sp>
-        <p:nvSpPr>
-          <p:cNvPr id="6" name="Rectangle 5"/>
+          <p:cNvPr id="5" name="Rectangle 4"/>
           <p:cNvSpPr/>
           <p:nvPr/>
         </p:nvSpPr>

</xml_diff>